<commit_message>
fix(deck): use a fresh shadow object per shape so PowerPoint opens the file
Co-Authored-By: Claude Sonnet 5.5 <noreply@anthropic.com>
</commit_message>
<xml_diff>
--- a/POS-Merchant-Hunter_Presentasi-Manajemen.pptx
+++ b/POS-Merchant-Hunter_Presentasi-Manajemen.pptx
@@ -4408,9 +4408,9 @@
             <a:prstDash val="solid"/>
           </a:ln>
           <a:effectLst>
-            <a:outerShdw sx="100000" sy="100000" kx="0" ky="0" algn="bl" rotWithShape="0" blurRad="1.4422566370265713e+169" dist="3.605641592566428e+168" dir="7.218447050975619e+197">
+            <a:outerShdw sx="100000" sy="100000" kx="0" ky="0" algn="bl" rotWithShape="0" blurRad="101600" dist="25400" dir="5400000">
               <a:srgbClr val="1B2A4A">
-                <a:alpha val="9.999999999999998e+203"/>
+                <a:alpha val="10000"/>
               </a:srgbClr>
             </a:outerShdw>
           </a:effectLst>
@@ -4671,9 +4671,9 @@
             <a:prstDash val="solid"/>
           </a:ln>
           <a:effectLst>
-            <a:outerShdw sx="100000" sy="100000" kx="0" ky="0" algn="bl" rotWithShape="0" blurRad="1.8316659290237455e+173" dist="4.579164822559364e+172" dir="4.3310682305853715e+202">
+            <a:outerShdw sx="100000" sy="100000" kx="0" ky="0" algn="bl" rotWithShape="0" blurRad="101600" dist="25400" dir="5400000">
               <a:srgbClr val="1B2A4A">
-                <a:alpha val="9.999999999999999e+208"/>
+                <a:alpha val="10000"/>
               </a:srgbClr>
             </a:outerShdw>
           </a:effectLst>
@@ -5086,9 +5086,9 @@
             <a:prstDash val="solid"/>
           </a:ln>
           <a:effectLst>
-            <a:outerShdw sx="100000" sy="100000" kx="0" ky="0" algn="bl" rotWithShape="0" blurRad="2.326215729860157e+177" dist="5.815539324650392e+176" dir="2.598640938351223e+207">
+            <a:outerShdw sx="100000" sy="100000" kx="0" ky="0" algn="bl" rotWithShape="0" blurRad="101600" dist="25400" dir="5400000">
               <a:srgbClr val="1B2A4A">
-                <a:alpha val="9.999999999999998e+213"/>
+                <a:alpha val="10000"/>
               </a:srgbClr>
             </a:outerShdw>
           </a:effectLst>
@@ -5222,9 +5222,9 @@
             <a:prstDash val="solid"/>
           </a:ln>
           <a:effectLst>
-            <a:outerShdw sx="100000" sy="100000" kx="0" ky="0" algn="bl" rotWithShape="0" blurRad="2.9542939769223992e+181" dist="7.385734942305998e+180" dir="1.5591845630107338e+212">
+            <a:outerShdw sx="100000" sy="100000" kx="0" ky="0" algn="bl" rotWithShape="0" blurRad="101600" dist="25400" dir="5400000">
               <a:srgbClr val="1B2A4A">
-                <a:alpha val="9.999999999999998e+218"/>
+                <a:alpha val="10000"/>
               </a:srgbClr>
             </a:outerShdw>
           </a:effectLst>
@@ -5334,9 +5334,9 @@
             <a:prstDash val="solid"/>
           </a:ln>
           <a:effectLst>
-            <a:outerShdw sx="100000" sy="100000" kx="0" ky="0" algn="bl" rotWithShape="0" blurRad="3.751953350691447e+185" dist="9.379883376728618e+184" dir="9.355107378064403e+216">
+            <a:outerShdw sx="100000" sy="100000" kx="0" ky="0" algn="bl" rotWithShape="0" blurRad="101600" dist="25400" dir="5400000">
               <a:srgbClr val="1B2A4A">
-                <a:alpha val="9.999999999999998e+223"/>
+                <a:alpha val="10000"/>
               </a:srgbClr>
             </a:outerShdw>
           </a:effectLst>
@@ -5446,9 +5446,9 @@
             <a:prstDash val="solid"/>
           </a:ln>
           <a:effectLst>
-            <a:outerShdw sx="100000" sy="100000" kx="0" ky="0" algn="bl" rotWithShape="0" blurRad="4.764980755378138e+189" dist="1.1912451888445345e+189" dir="5.613064426838642e+221">
+            <a:outerShdw sx="100000" sy="100000" kx="0" ky="0" algn="bl" rotWithShape="0" blurRad="101600" dist="25400" dir="5400000">
               <a:srgbClr val="1B2A4A">
-                <a:alpha val="9.999999999999997e+228"/>
+                <a:alpha val="10000"/>
               </a:srgbClr>
             </a:outerShdw>
           </a:effectLst>
@@ -5558,9 +5558,9 @@
             <a:prstDash val="solid"/>
           </a:ln>
           <a:effectLst>
-            <a:outerShdw sx="100000" sy="100000" kx="0" ky="0" algn="bl" rotWithShape="0" blurRad="6.051525559330235e+193" dist="1.5128813898325588e+193" dir="3.367838656103185e+226">
+            <a:outerShdw sx="100000" sy="100000" kx="0" ky="0" algn="bl" rotWithShape="0" blurRad="101600" dist="25400" dir="5400000">
               <a:srgbClr val="1B2A4A">
-                <a:alpha val="9.999999999999997e+233"/>
+                <a:alpha val="10000"/>
               </a:srgbClr>
             </a:outerShdw>
           </a:effectLst>
@@ -5670,9 +5670,9 @@
             <a:prstDash val="solid"/>
           </a:ln>
           <a:effectLst>
-            <a:outerShdw sx="100000" sy="100000" kx="0" ky="0" algn="bl" rotWithShape="0" blurRad="7.685437460349399e+197" dist="1.9213593650873497e+197" dir="2.020703193661911e+231">
+            <a:outerShdw sx="100000" sy="100000" kx="0" ky="0" algn="bl" rotWithShape="0" blurRad="101600" dist="25400" dir="5400000">
               <a:srgbClr val="1B2A4A">
-                <a:alpha val="9.999999999999996e+238"/>
+                <a:alpha val="10000"/>
               </a:srgbClr>
             </a:outerShdw>
           </a:effectLst>
@@ -5782,9 +5782,9 @@
             <a:prstDash val="solid"/>
           </a:ln>
           <a:effectLst>
-            <a:outerShdw sx="100000" sy="100000" kx="0" ky="0" algn="bl" rotWithShape="0" blurRad="9.760505574643736e+201" dist="2.440126393660934e+201" dir="1.2124219161971466e+236">
+            <a:outerShdw sx="100000" sy="100000" kx="0" ky="0" algn="bl" rotWithShape="0" blurRad="101600" dist="25400" dir="5400000">
               <a:srgbClr val="1B2A4A">
-                <a:alpha val="9.999999999999996e+243"/>
+                <a:alpha val="10000"/>
               </a:srgbClr>
             </a:outerShdw>
           </a:effectLst>
@@ -5894,9 +5894,9 @@
             <a:prstDash val="solid"/>
           </a:ln>
           <a:effectLst>
-            <a:outerShdw sx="100000" sy="100000" kx="0" ky="0" algn="bl" rotWithShape="0" blurRad="1.2395842079797546e+206" dist="3.0989605199493864e+205" dir="7.27453149718288e+240">
+            <a:outerShdw sx="100000" sy="100000" kx="0" ky="0" algn="bl" rotWithShape="0" blurRad="101600" dist="25400" dir="5400000">
               <a:srgbClr val="1B2A4A">
-                <a:alpha val="9.999999999999995e+248"/>
+                <a:alpha val="10000"/>
               </a:srgbClr>
             </a:outerShdw>
           </a:effectLst>
@@ -6387,9 +6387,9 @@
             <a:prstDash val="solid"/>
           </a:ln>
           <a:effectLst>
-            <a:outerShdw sx="100000" sy="100000" kx="0" ky="0" algn="bl" rotWithShape="0" blurRad="1.5742719441342882e+210" dist="3.9356798603357206e+209" dir="4.364718898309728e+245">
+            <a:outerShdw sx="100000" sy="100000" kx="0" ky="0" algn="bl" rotWithShape="0" blurRad="101600" dist="25400" dir="5400000">
               <a:srgbClr val="1B2A4A">
-                <a:alpha val="9.999999999999995e+253"/>
+                <a:alpha val="10000"/>
               </a:srgbClr>
             </a:outerShdw>
           </a:effectLst>
@@ -6484,9 +6484,9 @@
             <a:prstDash val="solid"/>
           </a:ln>
           <a:effectLst>
-            <a:outerShdw sx="100000" sy="100000" kx="0" ky="0" algn="bl" rotWithShape="0" blurRad="1.9993253690505461e+214" dist="4.9983134226263654e+213" dir="2.6188313389858368e+250">
+            <a:outerShdw sx="100000" sy="100000" kx="0" ky="0" algn="bl" rotWithShape="0" blurRad="101600" dist="25400" dir="5400000">
               <a:srgbClr val="1B2A4A">
-                <a:alpha val="9.999999999999996e+258"/>
+                <a:alpha val="10000"/>
               </a:srgbClr>
             </a:outerShdw>
           </a:effectLst>
@@ -6596,9 +6596,9 @@
             <a:prstDash val="solid"/>
           </a:ln>
           <a:effectLst>
-            <a:outerShdw sx="100000" sy="100000" kx="0" ky="0" algn="bl" rotWithShape="0" blurRad="2.5391432186941937e+218" dist="6.347858046735484e+217" dir="1.571298803391502e+255">
+            <a:outerShdw sx="100000" sy="100000" kx="0" ky="0" algn="bl" rotWithShape="0" blurRad="101600" dist="25400" dir="5400000">
               <a:srgbClr val="1B2A4A">
-                <a:alpha val="9.999999999999996e+263"/>
+                <a:alpha val="10000"/>
               </a:srgbClr>
             </a:outerShdw>
           </a:effectLst>
@@ -7195,9 +7195,9 @@
             <a:prstDash val="solid"/>
           </a:ln>
           <a:effectLst>
-            <a:outerShdw sx="100000" sy="100000" kx="0" ky="0" algn="bl" rotWithShape="0" blurRad="3.224711887741626e+222" dist="8.061779719354066e+221" dir="9.427792820349012e+259">
+            <a:outerShdw sx="100000" sy="100000" kx="0" ky="0" algn="bl" rotWithShape="0" blurRad="101600" dist="25400" dir="5400000">
               <a:srgbClr val="1B2A4A">
-                <a:alpha val="9.999999999999996e+268"/>
+                <a:alpha val="10000"/>
               </a:srgbClr>
             </a:outerShdw>
           </a:effectLst>
@@ -7346,9 +7346,9 @@
             <a:prstDash val="solid"/>
           </a:ln>
           <a:effectLst>
-            <a:outerShdw sx="100000" sy="100000" kx="0" ky="0" algn="bl" rotWithShape="0" blurRad="4.095384097431865e+226" dist="1.0238460243579663e+226" dir="5.656675692209407e+264">
+            <a:outerShdw sx="100000" sy="100000" kx="0" ky="0" algn="bl" rotWithShape="0" blurRad="101600" dist="25400" dir="5400000">
               <a:srgbClr val="1B2A4A">
-                <a:alpha val="9.999999999999995e+273"/>
+                <a:alpha val="10000"/>
               </a:srgbClr>
             </a:outerShdw>
           </a:effectLst>
@@ -7497,9 +7497,9 @@
             <a:prstDash val="solid"/>
           </a:ln>
           <a:effectLst>
-            <a:outerShdw sx="100000" sy="100000" kx="0" ky="0" algn="bl" rotWithShape="0" blurRad="5.201137803738469e+230" dist="1.3002844509346172e+230" dir="3.3940054153256444e+269">
+            <a:outerShdw sx="100000" sy="100000" kx="0" ky="0" algn="bl" rotWithShape="0" blurRad="101600" dist="25400" dir="5400000">
               <a:srgbClr val="1B2A4A">
-                <a:alpha val="9.999999999999996e+278"/>
+                <a:alpha val="10000"/>
               </a:srgbClr>
             </a:outerShdw>
           </a:effectLst>
@@ -7648,9 +7648,9 @@
             <a:prstDash val="solid"/>
           </a:ln>
           <a:effectLst>
-            <a:outerShdw sx="100000" sy="100000" kx="0" ky="0" algn="bl" rotWithShape="0" blurRad="6.605445010747855e+234" dist="1.6513612526869638e+234" dir="2.0364032491953868e+274">
+            <a:outerShdw sx="100000" sy="100000" kx="0" ky="0" algn="bl" rotWithShape="0" blurRad="101600" dist="25400" dir="5400000">
               <a:srgbClr val="1B2A4A">
-                <a:alpha val="9.999999999999996e+283"/>
+                <a:alpha val="10000"/>
               </a:srgbClr>
             </a:outerShdw>
           </a:effectLst>
@@ -7799,9 +7799,9 @@
             <a:prstDash val="solid"/>
           </a:ln>
           <a:effectLst>
-            <a:outerShdw sx="100000" sy="100000" kx="0" ky="0" algn="bl" rotWithShape="0" blurRad="8.388915163649776e+238" dist="2.097228790912444e+238" dir="1.221841949517232e+279">
+            <a:outerShdw sx="100000" sy="100000" kx="0" ky="0" algn="bl" rotWithShape="0" blurRad="101600" dist="25400" dir="5400000">
               <a:srgbClr val="1B2A4A">
-                <a:alpha val="9.999999999999996e+288"/>
+                <a:alpha val="10000"/>
               </a:srgbClr>
             </a:outerShdw>
           </a:effectLst>
@@ -8214,9 +8214,9 @@
             <a:prstDash val="solid"/>
           </a:ln>
           <a:effectLst>
-            <a:outerShdw sx="100000" sy="100000" kx="0" ky="0" algn="bl" rotWithShape="0" blurRad="1.0653922257835217e+243" dist="2.663480564458804e+242" dir="7.331051697103393e+283">
+            <a:outerShdw sx="100000" sy="100000" kx="0" ky="0" algn="bl" rotWithShape="0" blurRad="101600" dist="25400" dir="5400000">
               <a:srgbClr val="1B2A4A">
-                <a:alpha val="9.999999999999996e+293"/>
+                <a:alpha val="10000"/>
               </a:srgbClr>
             </a:outerShdw>
           </a:effectLst>
@@ -8887,9 +8887,9 @@
             <a:prstDash val="solid"/>
           </a:ln>
           <a:effectLst>
-            <a:outerShdw sx="100000" sy="100000" kx="0" ky="0" algn="bl" rotWithShape="0" blurRad="1.3530481267450725e+247" dist="3.3826203168626813e+246" dir="4.3986310182620354e+288">
+            <a:outerShdw sx="100000" sy="100000" kx="0" ky="0" algn="bl" rotWithShape="0" blurRad="101600" dist="25400" dir="5400000">
               <a:srgbClr val="1B2A4A">
-                <a:alpha val="9.999999999999997e+298"/>
+                <a:alpha val="10000"/>
               </a:srgbClr>
             </a:outerShdw>
           </a:effectLst>
@@ -9302,9 +9302,9 @@
             <a:prstDash val="solid"/>
           </a:ln>
           <a:effectLst>
-            <a:outerShdw sx="100000" sy="100000" kx="0" ky="0" algn="bl" rotWithShape="0" blurRad="1.718371120966242e+251" dist="4.295927802415605e+250" dir="2.6391786109572213e+293">
+            <a:outerShdw sx="100000" sy="100000" kx="0" ky="0" algn="bl" rotWithShape="0" blurRad="101600" dist="25400" dir="5400000">
               <a:srgbClr val="1B2A4A">
-                <a:alpha val="9.999999999999997e+303"/>
+                <a:alpha val="10000"/>
               </a:srgbClr>
             </a:outerShdw>
           </a:effectLst>
@@ -10359,9 +10359,9 @@
             <a:prstDash val="solid"/>
           </a:ln>
           <a:effectLst>
-            <a:outerShdw sx="100000" sy="100000" kx="0" ky="0" algn="bl" rotWithShape="0" blurRad="2.1823313236271275e+255" dist="5.455828309067819e+254" dir="1.5835071665743328e+298">
+            <a:outerShdw sx="100000" sy="100000" kx="0" ky="0" algn="bl" rotWithShape="0" blurRad="101600" dist="25400" dir="5400000">
               <a:srgbClr val="1B2A4A">
-                <a:alpha val="Infinity"/>
+                <a:alpha val="10000"/>
               </a:srgbClr>
             </a:outerShdw>
           </a:effectLst>
@@ -10648,9 +10648,9 @@
             <a:prstDash val="solid"/>
           </a:ln>
           <a:effectLst>
-            <a:outerShdw sx="100000" sy="100000" kx="0" ky="0" algn="bl" rotWithShape="0" blurRad="2.7715607810064518e+259" dist="6.928901952516129e+258" dir="9.501042999445996e+302">
+            <a:outerShdw sx="100000" sy="100000" kx="0" ky="0" algn="bl" rotWithShape="0" blurRad="101600" dist="25400" dir="5400000">
               <a:srgbClr val="1B2A4A">
-                <a:alpha val="Infinity"/>
+                <a:alpha val="10000"/>
               </a:srgbClr>
             </a:outerShdw>
           </a:effectLst>
@@ -10824,9 +10824,9 @@
             <a:prstDash val="solid"/>
           </a:ln>
           <a:effectLst>
-            <a:outerShdw sx="100000" sy="100000" kx="0" ky="0" algn="bl" rotWithShape="0" blurRad="3.519882191878194e+263" dist="8.799705479695485e+262" dir="5.700625799667598e+307">
+            <a:outerShdw sx="100000" sy="100000" kx="0" ky="0" algn="bl" rotWithShape="0" blurRad="101600" dist="25400" dir="5400000">
               <a:srgbClr val="1B2A4A">
-                <a:alpha val="Infinity"/>
+                <a:alpha val="10000"/>
               </a:srgbClr>
             </a:outerShdw>
           </a:effectLst>
@@ -11000,9 +11000,9 @@
             <a:prstDash val="solid"/>
           </a:ln>
           <a:effectLst>
-            <a:outerShdw sx="100000" sy="100000" kx="0" ky="0" algn="bl" rotWithShape="0" blurRad="4.470250383685306e+267" dist="1.1175625959213265e+267" dir="Infinity">
+            <a:outerShdw sx="100000" sy="100000" kx="0" ky="0" algn="bl" rotWithShape="0" blurRad="101600" dist="25400" dir="5400000">
               <a:srgbClr val="1B2A4A">
-                <a:alpha val="Infinity"/>
+                <a:alpha val="10000"/>
               </a:srgbClr>
             </a:outerShdw>
           </a:effectLst>
@@ -11518,9 +11518,9 @@
             <a:prstDash val="solid"/>
           </a:ln>
           <a:effectLst>
-            <a:outerShdw sx="100000" sy="100000" kx="0" ky="0" algn="bl" rotWithShape="0" blurRad="5.6772179872803385e+271" dist="1.4193044968200846e+271" dir="Infinity">
+            <a:outerShdw sx="100000" sy="100000" kx="0" ky="0" algn="bl" rotWithShape="0" blurRad="101600" dist="25400" dir="5400000">
               <a:srgbClr val="1B2A4A">
-                <a:alpha val="Infinity"/>
+                <a:alpha val="10000"/>
               </a:srgbClr>
             </a:outerShdw>
           </a:effectLst>
@@ -11694,9 +11694,9 @@
             <a:prstDash val="solid"/>
           </a:ln>
           <a:effectLst>
-            <a:outerShdw sx="100000" sy="100000" kx="0" ky="0" algn="bl" rotWithShape="0" blurRad="7.21006684384603e+275" dist="1.8025167109615074e+275" dir="Infinity">
+            <a:outerShdw sx="100000" sy="100000" kx="0" ky="0" algn="bl" rotWithShape="0" blurRad="101600" dist="25400" dir="5400000">
               <a:srgbClr val="1B2A4A">
-                <a:alpha val="Infinity"/>
+                <a:alpha val="10000"/>
               </a:srgbClr>
             </a:outerShdw>
           </a:effectLst>
@@ -11870,9 +11870,9 @@
             <a:prstDash val="solid"/>
           </a:ln>
           <a:effectLst>
-            <a:outerShdw sx="100000" sy="100000" kx="0" ky="0" algn="bl" rotWithShape="0" blurRad="9.156784891684457e+279" dist="2.2891962229211143e+279" dir="Infinity">
+            <a:outerShdw sx="100000" sy="100000" kx="0" ky="0" algn="bl" rotWithShape="0" blurRad="101600" dist="25400" dir="5400000">
               <a:srgbClr val="1B2A4A">
-                <a:alpha val="Infinity"/>
+                <a:alpha val="10000"/>
               </a:srgbClr>
             </a:outerShdw>
           </a:effectLst>
@@ -12046,9 +12046,9 @@
             <a:prstDash val="solid"/>
           </a:ln>
           <a:effectLst>
-            <a:outerShdw sx="100000" sy="100000" kx="0" ky="0" algn="bl" rotWithShape="0" blurRad="1.1629116812439261e+284" dist="2.9072792031098153e+283" dir="Infinity">
+            <a:outerShdw sx="100000" sy="100000" kx="0" ky="0" algn="bl" rotWithShape="0" blurRad="101600" dist="25400" dir="5400000">
               <a:srgbClr val="1B2A4A">
-                <a:alpha val="Infinity"/>
+                <a:alpha val="10000"/>
               </a:srgbClr>
             </a:outerShdw>
           </a:effectLst>
@@ -12261,9 +12261,9 @@
             <a:prstDash val="solid"/>
           </a:ln>
           <a:effectLst>
-            <a:outerShdw sx="100000" sy="100000" kx="0" ky="0" algn="bl" rotWithShape="0" blurRad="1.4768978351797863e+288" dist="3.6922445879494656e+287" dir="Infinity">
+            <a:outerShdw sx="100000" sy="100000" kx="0" ky="0" algn="bl" rotWithShape="0" blurRad="101600" dist="25400" dir="5400000">
               <a:srgbClr val="1B2A4A">
-                <a:alpha val="Infinity"/>
+                <a:alpha val="10000"/>
               </a:srgbClr>
             </a:outerShdw>
           </a:effectLst>
@@ -12373,9 +12373,9 @@
             <a:prstDash val="solid"/>
           </a:ln>
           <a:effectLst>
-            <a:outerShdw sx="100000" sy="100000" kx="0" ky="0" algn="bl" rotWithShape="0" blurRad="1.8756602506783286e+292" dist="4.6891506266958215e+291" dir="Infinity">
+            <a:outerShdw sx="100000" sy="100000" kx="0" ky="0" algn="bl" rotWithShape="0" blurRad="101600" dist="25400" dir="5400000">
               <a:srgbClr val="1B2A4A">
-                <a:alpha val="Infinity"/>
+                <a:alpha val="10000"/>
               </a:srgbClr>
             </a:outerShdw>
           </a:effectLst>
@@ -12485,9 +12485,9 @@
             <a:prstDash val="solid"/>
           </a:ln>
           <a:effectLst>
-            <a:outerShdw sx="100000" sy="100000" kx="0" ky="0" algn="bl" rotWithShape="0" blurRad="2.3820885183614773e+296" dist="5.955221295903693e+295" dir="Infinity">
+            <a:outerShdw sx="100000" sy="100000" kx="0" ky="0" algn="bl" rotWithShape="0" blurRad="101600" dist="25400" dir="5400000">
               <a:srgbClr val="1B2A4A">
-                <a:alpha val="Infinity"/>
+                <a:alpha val="10000"/>
               </a:srgbClr>
             </a:outerShdw>
           </a:effectLst>
@@ -12597,9 +12597,9 @@
             <a:prstDash val="solid"/>
           </a:ln>
           <a:effectLst>
-            <a:outerShdw sx="100000" sy="100000" kx="0" ky="0" algn="bl" rotWithShape="0" blurRad="3.025252418319076e+300" dist="7.56313104579769e+299" dir="Infinity">
+            <a:outerShdw sx="100000" sy="100000" kx="0" ky="0" algn="bl" rotWithShape="0" blurRad="101600" dist="25400" dir="5400000">
               <a:srgbClr val="1B2A4A">
-                <a:alpha val="Infinity"/>
+                <a:alpha val="10000"/>
               </a:srgbClr>
             </a:outerShdw>
           </a:effectLst>
@@ -12709,9 +12709,9 @@
             <a:prstDash val="solid"/>
           </a:ln>
           <a:effectLst>
-            <a:outerShdw sx="100000" sy="100000" kx="0" ky="0" algn="bl" rotWithShape="0" blurRad="3.842070571265227e+304" dist="9.605176428163068e+303" dir="Infinity">
+            <a:outerShdw sx="100000" sy="100000" kx="0" ky="0" algn="bl" rotWithShape="0" blurRad="101600" dist="25400" dir="5400000">
               <a:srgbClr val="1B2A4A">
-                <a:alpha val="Infinity"/>
+                <a:alpha val="10000"/>
               </a:srgbClr>
             </a:outerShdw>
           </a:effectLst>
@@ -12821,9 +12821,9 @@
             <a:prstDash val="solid"/>
           </a:ln>
           <a:effectLst>
-            <a:outerShdw sx="100000" sy="100000" kx="0" ky="0" algn="bl" rotWithShape="0" blurRad="Infinity" dist="1.2198574063767096e+308" dir="Infinity">
+            <a:outerShdw sx="100000" sy="100000" kx="0" ky="0" algn="bl" rotWithShape="0" blurRad="101600" dist="25400" dir="5400000">
               <a:srgbClr val="1B2A4A">
-                <a:alpha val="Infinity"/>
+                <a:alpha val="10000"/>
               </a:srgbClr>
             </a:outerShdw>
           </a:effectLst>
@@ -13275,9 +13275,9 @@
             <a:prstDash val="solid"/>
           </a:ln>
           <a:effectLst>
-            <a:outerShdw sx="100000" sy="100000" kx="0" ky="0" algn="bl" rotWithShape="0" blurRad="Infinity" dist="Infinity" dir="Infinity">
+            <a:outerShdw sx="100000" sy="100000" kx="0" ky="0" algn="bl" rotWithShape="0" blurRad="101600" dist="25400" dir="5400000">
               <a:srgbClr val="1B2A4A">
-                <a:alpha val="Infinity"/>
+                <a:alpha val="10000"/>
               </a:srgbClr>
             </a:outerShdw>
           </a:effectLst>
@@ -13451,9 +13451,9 @@
             <a:prstDash val="solid"/>
           </a:ln>
           <a:effectLst>
-            <a:outerShdw sx="100000" sy="100000" kx="0" ky="0" algn="bl" rotWithShape="0" blurRad="Infinity" dist="Infinity" dir="Infinity">
+            <a:outerShdw sx="100000" sy="100000" kx="0" ky="0" algn="bl" rotWithShape="0" blurRad="101600" dist="25400" dir="5400000">
               <a:srgbClr val="1B2A4A">
-                <a:alpha val="Infinity"/>
+                <a:alpha val="10000"/>
               </a:srgbClr>
             </a:outerShdw>
           </a:effectLst>
@@ -13627,9 +13627,9 @@
             <a:prstDash val="solid"/>
           </a:ln>
           <a:effectLst>
-            <a:outerShdw sx="100000" sy="100000" kx="0" ky="0" algn="bl" rotWithShape="0" blurRad="Infinity" dist="Infinity" dir="Infinity">
+            <a:outerShdw sx="100000" sy="100000" kx="0" ky="0" algn="bl" rotWithShape="0" blurRad="101600" dist="25400" dir="5400000">
               <a:srgbClr val="1B2A4A">
-                <a:alpha val="Infinity"/>
+                <a:alpha val="10000"/>
               </a:srgbClr>
             </a:outerShdw>
           </a:effectLst>
@@ -13803,9 +13803,9 @@
             <a:prstDash val="solid"/>
           </a:ln>
           <a:effectLst>
-            <a:outerShdw sx="100000" sy="100000" kx="0" ky="0" algn="bl" rotWithShape="0" blurRad="Infinity" dist="Infinity" dir="Infinity">
+            <a:outerShdw sx="100000" sy="100000" kx="0" ky="0" algn="bl" rotWithShape="0" blurRad="101600" dist="25400" dir="5400000">
               <a:srgbClr val="1B2A4A">
-                <a:alpha val="Infinity"/>
+                <a:alpha val="10000"/>
               </a:srgbClr>
             </a:outerShdw>
           </a:effectLst>
@@ -13915,9 +13915,9 @@
             <a:prstDash val="solid"/>
           </a:ln>
           <a:effectLst>
-            <a:outerShdw sx="100000" sy="100000" kx="0" ky="0" algn="bl" rotWithShape="0" blurRad="Infinity" dist="Infinity" dir="Infinity">
+            <a:outerShdw sx="100000" sy="100000" kx="0" ky="0" algn="bl" rotWithShape="0" blurRad="101600" dist="25400" dir="5400000">
               <a:srgbClr val="1B2A4A">
-                <a:alpha val="Infinity"/>
+                <a:alpha val="10000"/>
               </a:srgbClr>
             </a:outerShdw>
           </a:effectLst>
@@ -14376,9 +14376,9 @@
             <a:prstDash val="solid"/>
           </a:ln>
           <a:effectLst>
-            <a:outerShdw sx="100000" sy="100000" kx="0" ky="0" algn="bl" rotWithShape="0" blurRad="Infinity" dist="Infinity" dir="Infinity">
+            <a:outerShdw sx="100000" sy="100000" kx="0" ky="0" algn="bl" rotWithShape="0" blurRad="101600" dist="25400" dir="5400000">
               <a:srgbClr val="1B2A4A">
-                <a:alpha val="Infinity"/>
+                <a:alpha val="10000"/>
               </a:srgbClr>
             </a:outerShdw>
           </a:effectLst>
@@ -15141,9 +15141,9 @@
             <a:prstDash val="solid"/>
           </a:ln>
           <a:effectLst>
-            <a:outerShdw sx="100000" sy="100000" kx="0" ky="0" algn="bl" rotWithShape="0" blurRad="1290320000" dist="322580000" dir="324000000000">
+            <a:outerShdw sx="100000" sy="100000" kx="0" ky="0" algn="bl" rotWithShape="0" blurRad="101600" dist="25400" dir="5400000">
               <a:srgbClr val="1B2A4A">
-                <a:alpha val="1000000000"/>
+                <a:alpha val="10000"/>
               </a:srgbClr>
             </a:outerShdw>
           </a:effectLst>
@@ -15301,9 +15301,9 @@
             <a:prstDash val="solid"/>
           </a:ln>
           <a:effectLst>
-            <a:outerShdw sx="100000" sy="100000" kx="0" ky="0" algn="bl" rotWithShape="0" blurRad="16387064000000" dist="4096766000000" dir="19440000000000000">
+            <a:outerShdw sx="100000" sy="100000" kx="0" ky="0" algn="bl" rotWithShape="0" blurRad="101600" dist="25400" dir="5400000">
               <a:srgbClr val="1B2A4A">
-                <a:alpha val="100000000000000"/>
+                <a:alpha val="10000"/>
               </a:srgbClr>
             </a:outerShdw>
           </a:effectLst>
@@ -15461,9 +15461,9 @@
             <a:prstDash val="solid"/>
           </a:ln>
           <a:effectLst>
-            <a:outerShdw sx="100000" sy="100000" kx="0" ky="0" algn="bl" rotWithShape="0" blurRad="208115712800000000" dist="52028928200000000" dir="1.1664e+21">
+            <a:outerShdw sx="100000" sy="100000" kx="0" ky="0" algn="bl" rotWithShape="0" blurRad="101600" dist="25400" dir="5400000">
               <a:srgbClr val="1B2A4A">
-                <a:alpha val="10000000000000000000"/>
+                <a:alpha val="10000"/>
               </a:srgbClr>
             </a:outerShdw>
           </a:effectLst>
@@ -15621,9 +15621,9 @@
             <a:prstDash val="solid"/>
           </a:ln>
           <a:effectLst>
-            <a:outerShdw sx="100000" sy="100000" kx="0" ky="0" algn="bl" rotWithShape="0" blurRad="2.64306955256e+21" dist="660767388140000000000" dir="6.9984e+25">
+            <a:outerShdw sx="100000" sy="100000" kx="0" ky="0" algn="bl" rotWithShape="0" blurRad="101600" dist="25400" dir="5400000">
               <a:srgbClr val="1B2A4A">
-                <a:alpha val="1e+24"/>
+                <a:alpha val="10000"/>
               </a:srgbClr>
             </a:outerShdw>
           </a:effectLst>
@@ -15781,9 +15781,9 @@
             <a:prstDash val="solid"/>
           </a:ln>
           <a:effectLst>
-            <a:outerShdw sx="100000" sy="100000" kx="0" ky="0" algn="bl" rotWithShape="0" blurRad="3.3566983317512e+25" dist="8.391745829378e+24" dir="4.19904e+30">
+            <a:outerShdw sx="100000" sy="100000" kx="0" ky="0" algn="bl" rotWithShape="0" blurRad="101600" dist="25400" dir="5400000">
               <a:srgbClr val="1B2A4A">
-                <a:alpha val="1e+29"/>
+                <a:alpha val="10000"/>
               </a:srgbClr>
             </a:outerShdw>
           </a:effectLst>
@@ -15941,9 +15941,9 @@
             <a:prstDash val="solid"/>
           </a:ln>
           <a:effectLst>
-            <a:outerShdw sx="100000" sy="100000" kx="0" ky="0" algn="bl" rotWithShape="0" blurRad="4.2630068813240236e+29" dist="1.0657517203310059e+29" dir="2.519424e+35">
+            <a:outerShdw sx="100000" sy="100000" kx="0" ky="0" algn="bl" rotWithShape="0" blurRad="101600" dist="25400" dir="5400000">
               <a:srgbClr val="1B2A4A">
-                <a:alpha val="1e+34"/>
+                <a:alpha val="10000"/>
               </a:srgbClr>
             </a:outerShdw>
           </a:effectLst>
@@ -16443,9 +16443,9 @@
             <a:prstDash val="solid"/>
           </a:ln>
           <a:effectLst>
-            <a:outerShdw sx="100000" sy="100000" kx="0" ky="0" algn="bl" rotWithShape="0" blurRad="Infinity" dist="Infinity" dir="Infinity">
+            <a:outerShdw sx="100000" sy="100000" kx="0" ky="0" algn="bl" rotWithShape="0" blurRad="101600" dist="25400" dir="5400000">
               <a:srgbClr val="1B2A4A">
-                <a:alpha val="Infinity"/>
+                <a:alpha val="10000"/>
               </a:srgbClr>
             </a:outerShdw>
           </a:effectLst>
@@ -16540,9 +16540,9 @@
             <a:prstDash val="solid"/>
           </a:ln>
           <a:effectLst>
-            <a:outerShdw sx="100000" sy="100000" kx="0" ky="0" algn="bl" rotWithShape="0" blurRad="Infinity" dist="Infinity" dir="Infinity">
+            <a:outerShdw sx="100000" sy="100000" kx="0" ky="0" algn="bl" rotWithShape="0" blurRad="101600" dist="25400" dir="5400000">
               <a:srgbClr val="1B2A4A">
-                <a:alpha val="Infinity"/>
+                <a:alpha val="10000"/>
               </a:srgbClr>
             </a:outerShdw>
           </a:effectLst>
@@ -16716,9 +16716,9 @@
             <a:prstDash val="solid"/>
           </a:ln>
           <a:effectLst>
-            <a:outerShdw sx="100000" sy="100000" kx="0" ky="0" algn="bl" rotWithShape="0" blurRad="Infinity" dist="Infinity" dir="Infinity">
+            <a:outerShdw sx="100000" sy="100000" kx="0" ky="0" algn="bl" rotWithShape="0" blurRad="101600" dist="25400" dir="5400000">
               <a:srgbClr val="1B2A4A">
-                <a:alpha val="Infinity"/>
+                <a:alpha val="10000"/>
               </a:srgbClr>
             </a:outerShdw>
           </a:effectLst>
@@ -16892,9 +16892,9 @@
             <a:prstDash val="solid"/>
           </a:ln>
           <a:effectLst>
-            <a:outerShdw sx="100000" sy="100000" kx="0" ky="0" algn="bl" rotWithShape="0" blurRad="Infinity" dist="Infinity" dir="Infinity">
+            <a:outerShdw sx="100000" sy="100000" kx="0" ky="0" algn="bl" rotWithShape="0" blurRad="101600" dist="25400" dir="5400000">
               <a:srgbClr val="1B2A4A">
-                <a:alpha val="Infinity"/>
+                <a:alpha val="10000"/>
               </a:srgbClr>
             </a:outerShdw>
           </a:effectLst>
@@ -17410,9 +17410,9 @@
             <a:prstDash val="solid"/>
           </a:ln>
           <a:effectLst>
-            <a:outerShdw sx="100000" sy="100000" kx="0" ky="0" algn="bl" rotWithShape="0" blurRad="Infinity" dist="Infinity" dir="Infinity">
+            <a:outerShdw sx="100000" sy="100000" kx="0" ky="0" algn="bl" rotWithShape="0" blurRad="101600" dist="25400" dir="5400000">
               <a:srgbClr val="1B2A4A">
-                <a:alpha val="Infinity"/>
+                <a:alpha val="10000"/>
               </a:srgbClr>
             </a:outerShdw>
           </a:effectLst>
@@ -17468,9 +17468,9 @@
             <a:prstDash val="solid"/>
           </a:ln>
           <a:effectLst>
-            <a:outerShdw sx="100000" sy="100000" kx="0" ky="0" algn="bl" rotWithShape="0" blurRad="Infinity" dist="Infinity" dir="Infinity">
+            <a:outerShdw sx="100000" sy="100000" kx="0" ky="0" algn="bl" rotWithShape="0" blurRad="101600" dist="25400" dir="5400000">
               <a:srgbClr val="1B2A4A">
-                <a:alpha val="Infinity"/>
+                <a:alpha val="10000"/>
               </a:srgbClr>
             </a:outerShdw>
           </a:effectLst>
@@ -17604,9 +17604,9 @@
             <a:prstDash val="solid"/>
           </a:ln>
           <a:effectLst>
-            <a:outerShdw sx="100000" sy="100000" kx="0" ky="0" algn="bl" rotWithShape="0" blurRad="Infinity" dist="Infinity" dir="Infinity">
+            <a:outerShdw sx="100000" sy="100000" kx="0" ky="0" algn="bl" rotWithShape="0" blurRad="101600" dist="25400" dir="5400000">
               <a:srgbClr val="1B2A4A">
-                <a:alpha val="Infinity"/>
+                <a:alpha val="10000"/>
               </a:srgbClr>
             </a:outerShdw>
           </a:effectLst>
@@ -18019,9 +18019,9 @@
             <a:prstDash val="solid"/>
           </a:ln>
           <a:effectLst>
-            <a:outerShdw sx="100000" sy="100000" kx="0" ky="0" algn="bl" rotWithShape="0" blurRad="Infinity" dist="Infinity" dir="Infinity">
+            <a:outerShdw sx="100000" sy="100000" kx="0" ky="0" algn="bl" rotWithShape="0" blurRad="101600" dist="25400" dir="5400000">
               <a:srgbClr val="1B2A4A">
-                <a:alpha val="Infinity"/>
+                <a:alpha val="10000"/>
               </a:srgbClr>
             </a:outerShdw>
           </a:effectLst>
@@ -18131,9 +18131,9 @@
             <a:prstDash val="solid"/>
           </a:ln>
           <a:effectLst>
-            <a:outerShdw sx="100000" sy="100000" kx="0" ky="0" algn="bl" rotWithShape="0" blurRad="Infinity" dist="Infinity" dir="Infinity">
+            <a:outerShdw sx="100000" sy="100000" kx="0" ky="0" algn="bl" rotWithShape="0" blurRad="101600" dist="25400" dir="5400000">
               <a:srgbClr val="1B2A4A">
-                <a:alpha val="Infinity"/>
+                <a:alpha val="10000"/>
               </a:srgbClr>
             </a:outerShdw>
           </a:effectLst>
@@ -18243,9 +18243,9 @@
             <a:prstDash val="solid"/>
           </a:ln>
           <a:effectLst>
-            <a:outerShdw sx="100000" sy="100000" kx="0" ky="0" algn="bl" rotWithShape="0" blurRad="Infinity" dist="Infinity" dir="Infinity">
+            <a:outerShdw sx="100000" sy="100000" kx="0" ky="0" algn="bl" rotWithShape="0" blurRad="101600" dist="25400" dir="5400000">
               <a:srgbClr val="1B2A4A">
-                <a:alpha val="Infinity"/>
+                <a:alpha val="10000"/>
               </a:srgbClr>
             </a:outerShdw>
           </a:effectLst>
@@ -18355,9 +18355,9 @@
             <a:prstDash val="solid"/>
           </a:ln>
           <a:effectLst>
-            <a:outerShdw sx="100000" sy="100000" kx="0" ky="0" algn="bl" rotWithShape="0" blurRad="Infinity" dist="Infinity" dir="Infinity">
+            <a:outerShdw sx="100000" sy="100000" kx="0" ky="0" algn="bl" rotWithShape="0" blurRad="101600" dist="25400" dir="5400000">
               <a:srgbClr val="1B2A4A">
-                <a:alpha val="Infinity"/>
+                <a:alpha val="10000"/>
               </a:srgbClr>
             </a:outerShdw>
           </a:effectLst>
@@ -18467,9 +18467,9 @@
             <a:prstDash val="solid"/>
           </a:ln>
           <a:effectLst>
-            <a:outerShdw sx="100000" sy="100000" kx="0" ky="0" algn="bl" rotWithShape="0" blurRad="Infinity" dist="Infinity" dir="Infinity">
+            <a:outerShdw sx="100000" sy="100000" kx="0" ky="0" algn="bl" rotWithShape="0" blurRad="101600" dist="25400" dir="5400000">
               <a:srgbClr val="1B2A4A">
-                <a:alpha val="Infinity"/>
+                <a:alpha val="10000"/>
               </a:srgbClr>
             </a:outerShdw>
           </a:effectLst>
@@ -18579,9 +18579,9 @@
             <a:prstDash val="solid"/>
           </a:ln>
           <a:effectLst>
-            <a:outerShdw sx="100000" sy="100000" kx="0" ky="0" algn="bl" rotWithShape="0" blurRad="Infinity" dist="Infinity" dir="Infinity">
+            <a:outerShdw sx="100000" sy="100000" kx="0" ky="0" algn="bl" rotWithShape="0" blurRad="101600" dist="25400" dir="5400000">
               <a:srgbClr val="1B2A4A">
-                <a:alpha val="Infinity"/>
+                <a:alpha val="10000"/>
               </a:srgbClr>
             </a:outerShdw>
           </a:effectLst>
@@ -19189,9 +19189,9 @@
             <a:prstDash val="solid"/>
           </a:ln>
           <a:effectLst>
-            <a:outerShdw sx="100000" sy="100000" kx="0" ky="0" algn="bl" rotWithShape="0" blurRad="Infinity" dist="Infinity" dir="Infinity">
+            <a:outerShdw sx="100000" sy="100000" kx="0" ky="0" algn="bl" rotWithShape="0" blurRad="101600" dist="25400" dir="5400000">
               <a:srgbClr val="1B2A4A">
-                <a:alpha val="Infinity"/>
+                <a:alpha val="10000"/>
               </a:srgbClr>
             </a:outerShdw>
           </a:effectLst>
@@ -19301,9 +19301,9 @@
             <a:prstDash val="solid"/>
           </a:ln>
           <a:effectLst>
-            <a:outerShdw sx="100000" sy="100000" kx="0" ky="0" algn="bl" rotWithShape="0" blurRad="Infinity" dist="Infinity" dir="Infinity">
+            <a:outerShdw sx="100000" sy="100000" kx="0" ky="0" algn="bl" rotWithShape="0" blurRad="101600" dist="25400" dir="5400000">
               <a:srgbClr val="1B2A4A">
-                <a:alpha val="Infinity"/>
+                <a:alpha val="10000"/>
               </a:srgbClr>
             </a:outerShdw>
           </a:effectLst>
@@ -19413,9 +19413,9 @@
             <a:prstDash val="solid"/>
           </a:ln>
           <a:effectLst>
-            <a:outerShdw sx="100000" sy="100000" kx="0" ky="0" algn="bl" rotWithShape="0" blurRad="Infinity" dist="Infinity" dir="Infinity">
+            <a:outerShdw sx="100000" sy="100000" kx="0" ky="0" algn="bl" rotWithShape="0" blurRad="101600" dist="25400" dir="5400000">
               <a:srgbClr val="1B2A4A">
-                <a:alpha val="Infinity"/>
+                <a:alpha val="10000"/>
               </a:srgbClr>
             </a:outerShdw>
           </a:effectLst>
@@ -19525,9 +19525,9 @@
             <a:prstDash val="solid"/>
           </a:ln>
           <a:effectLst>
-            <a:outerShdw sx="100000" sy="100000" kx="0" ky="0" algn="bl" rotWithShape="0" blurRad="Infinity" dist="Infinity" dir="Infinity">
+            <a:outerShdw sx="100000" sy="100000" kx="0" ky="0" algn="bl" rotWithShape="0" blurRad="101600" dist="25400" dir="5400000">
               <a:srgbClr val="1B2A4A">
-                <a:alpha val="Infinity"/>
+                <a:alpha val="10000"/>
               </a:srgbClr>
             </a:outerShdw>
           </a:effectLst>
@@ -19637,9 +19637,9 @@
             <a:prstDash val="solid"/>
           </a:ln>
           <a:effectLst>
-            <a:outerShdw sx="100000" sy="100000" kx="0" ky="0" algn="bl" rotWithShape="0" blurRad="Infinity" dist="Infinity" dir="Infinity">
+            <a:outerShdw sx="100000" sy="100000" kx="0" ky="0" algn="bl" rotWithShape="0" blurRad="101600" dist="25400" dir="5400000">
               <a:srgbClr val="1B2A4A">
-                <a:alpha val="Infinity"/>
+                <a:alpha val="10000"/>
               </a:srgbClr>
             </a:outerShdw>
           </a:effectLst>
@@ -19837,9 +19837,9 @@
             <a:prstDash val="solid"/>
           </a:ln>
           <a:effectLst>
-            <a:outerShdw sx="100000" sy="100000" kx="0" ky="0" algn="bl" rotWithShape="0" blurRad="Infinity" dist="Infinity" dir="Infinity">
+            <a:outerShdw sx="100000" sy="100000" kx="0" ky="0" algn="bl" rotWithShape="0" blurRad="101600" dist="25400" dir="5400000">
               <a:srgbClr val="1B2A4A">
-                <a:alpha val="Infinity"/>
+                <a:alpha val="10000"/>
               </a:srgbClr>
             </a:outerShdw>
           </a:effectLst>
@@ -20379,9 +20379,9 @@
             <a:prstDash val="solid"/>
           </a:ln>
           <a:effectLst>
-            <a:outerShdw sx="100000" sy="100000" kx="0" ky="0" algn="bl" rotWithShape="0" blurRad="Infinity" dist="Infinity" dir="Infinity">
+            <a:outerShdw sx="100000" sy="100000" kx="0" ky="0" algn="bl" rotWithShape="0" blurRad="101600" dist="25400" dir="5400000">
               <a:srgbClr val="1B2A4A">
-                <a:alpha val="Infinity"/>
+                <a:alpha val="10000"/>
               </a:srgbClr>
             </a:outerShdw>
           </a:effectLst>
@@ -20569,9 +20569,9 @@
             <a:prstDash val="solid"/>
           </a:ln>
           <a:effectLst>
-            <a:outerShdw sx="100000" sy="100000" kx="0" ky="0" algn="bl" rotWithShape="0" blurRad="Infinity" dist="Infinity" dir="Infinity">
+            <a:outerShdw sx="100000" sy="100000" kx="0" ky="0" algn="bl" rotWithShape="0" blurRad="101600" dist="25400" dir="5400000">
               <a:srgbClr val="1B2A4A">
-                <a:alpha val="Infinity"/>
+                <a:alpha val="10000"/>
               </a:srgbClr>
             </a:outerShdw>
           </a:effectLst>
@@ -20759,9 +20759,9 @@
             <a:prstDash val="solid"/>
           </a:ln>
           <a:effectLst>
-            <a:outerShdw sx="100000" sy="100000" kx="0" ky="0" algn="bl" rotWithShape="0" blurRad="Infinity" dist="Infinity" dir="Infinity">
+            <a:outerShdw sx="100000" sy="100000" kx="0" ky="0" algn="bl" rotWithShape="0" blurRad="101600" dist="25400" dir="5400000">
               <a:srgbClr val="1B2A4A">
-                <a:alpha val="Infinity"/>
+                <a:alpha val="10000"/>
               </a:srgbClr>
             </a:outerShdw>
           </a:effectLst>
@@ -20910,9 +20910,9 @@
             <a:prstDash val="solid"/>
           </a:ln>
           <a:effectLst>
-            <a:outerShdw sx="100000" sy="100000" kx="0" ky="0" algn="bl" rotWithShape="0" blurRad="Infinity" dist="Infinity" dir="Infinity">
+            <a:outerShdw sx="100000" sy="100000" kx="0" ky="0" algn="bl" rotWithShape="0" blurRad="101600" dist="25400" dir="5400000">
               <a:srgbClr val="1B2A4A">
-                <a:alpha val="Infinity"/>
+                <a:alpha val="10000"/>
               </a:srgbClr>
             </a:outerShdw>
           </a:effectLst>
@@ -21068,9 +21068,9 @@
             <a:prstDash val="solid"/>
           </a:ln>
           <a:effectLst>
-            <a:outerShdw sx="100000" sy="100000" kx="0" ky="0" algn="bl" rotWithShape="0" blurRad="Infinity" dist="Infinity" dir="Infinity">
+            <a:outerShdw sx="100000" sy="100000" kx="0" ky="0" algn="bl" rotWithShape="0" blurRad="101600" dist="25400" dir="5400000">
               <a:srgbClr val="1B2A4A">
-                <a:alpha val="Infinity"/>
+                <a:alpha val="10000"/>
               </a:srgbClr>
             </a:outerShdw>
           </a:effectLst>
@@ -21568,9 +21568,9 @@
             <a:prstDash val="solid"/>
           </a:ln>
           <a:effectLst>
-            <a:outerShdw sx="100000" sy="100000" kx="0" ky="0" algn="bl" rotWithShape="0" blurRad="Infinity" dist="Infinity" dir="Infinity">
+            <a:outerShdw sx="100000" sy="100000" kx="0" ky="0" algn="bl" rotWithShape="0" blurRad="101600" dist="25400" dir="5400000">
               <a:srgbClr val="1B2A4A">
-                <a:alpha val="Infinity"/>
+                <a:alpha val="10000"/>
               </a:srgbClr>
             </a:outerShdw>
           </a:effectLst>
@@ -21825,9 +21825,9 @@
             <a:prstDash val="solid"/>
           </a:ln>
           <a:effectLst>
-            <a:outerShdw sx="100000" sy="100000" kx="0" ky="0" algn="bl" rotWithShape="0" blurRad="Infinity" dist="Infinity" dir="Infinity">
+            <a:outerShdw sx="100000" sy="100000" kx="0" ky="0" algn="bl" rotWithShape="0" blurRad="101600" dist="25400" dir="5400000">
               <a:srgbClr val="1B2A4A">
-                <a:alpha val="Infinity"/>
+                <a:alpha val="10000"/>
               </a:srgbClr>
             </a:outerShdw>
           </a:effectLst>
@@ -22950,9 +22950,9 @@
             <a:prstDash val="solid"/>
           </a:ln>
           <a:effectLst>
-            <a:outerShdw sx="100000" sy="100000" kx="0" ky="0" algn="bl" rotWithShape="0" blurRad="Infinity" dist="Infinity" dir="Infinity">
+            <a:outerShdw sx="100000" sy="100000" kx="0" ky="0" algn="bl" rotWithShape="0" blurRad="101600" dist="25400" dir="5400000">
               <a:srgbClr val="1B2A4A">
-                <a:alpha val="Infinity"/>
+                <a:alpha val="10000"/>
               </a:srgbClr>
             </a:outerShdw>
           </a:effectLst>
@@ -23435,9 +23435,9 @@
             <a:prstDash val="solid"/>
           </a:ln>
           <a:effectLst>
-            <a:outerShdw sx="100000" sy="100000" kx="0" ky="0" algn="bl" rotWithShape="0" blurRad="Infinity" dist="Infinity" dir="Infinity">
+            <a:outerShdw sx="100000" sy="100000" kx="0" ky="0" algn="bl" rotWithShape="0" blurRad="101600" dist="25400" dir="5400000">
               <a:srgbClr val="1B2A4A">
-                <a:alpha val="Infinity"/>
+                <a:alpha val="10000"/>
               </a:srgbClr>
             </a:outerShdw>
           </a:effectLst>
@@ -24162,9 +24162,9 @@
             <a:prstDash val="solid"/>
           </a:ln>
           <a:effectLst>
-            <a:outerShdw sx="100000" sy="100000" kx="0" ky="0" algn="bl" rotWithShape="0" blurRad="Infinity" dist="Infinity" dir="Infinity">
+            <a:outerShdw sx="100000" sy="100000" kx="0" ky="0" algn="bl" rotWithShape="0" blurRad="101600" dist="25400" dir="5400000">
               <a:srgbClr val="1B2A4A">
-                <a:alpha val="Infinity"/>
+                <a:alpha val="10000"/>
               </a:srgbClr>
             </a:outerShdw>
           </a:effectLst>
@@ -24274,9 +24274,9 @@
             <a:prstDash val="solid"/>
           </a:ln>
           <a:effectLst>
-            <a:outerShdw sx="100000" sy="100000" kx="0" ky="0" algn="bl" rotWithShape="0" blurRad="Infinity" dist="Infinity" dir="Infinity">
+            <a:outerShdw sx="100000" sy="100000" kx="0" ky="0" algn="bl" rotWithShape="0" blurRad="101600" dist="25400" dir="5400000">
               <a:srgbClr val="1B2A4A">
-                <a:alpha val="Infinity"/>
+                <a:alpha val="10000"/>
               </a:srgbClr>
             </a:outerShdw>
           </a:effectLst>
@@ -24386,9 +24386,9 @@
             <a:prstDash val="solid"/>
           </a:ln>
           <a:effectLst>
-            <a:outerShdw sx="100000" sy="100000" kx="0" ky="0" algn="bl" rotWithShape="0" blurRad="Infinity" dist="Infinity" dir="Infinity">
+            <a:outerShdw sx="100000" sy="100000" kx="0" ky="0" algn="bl" rotWithShape="0" blurRad="101600" dist="25400" dir="5400000">
               <a:srgbClr val="1B2A4A">
-                <a:alpha val="Infinity"/>
+                <a:alpha val="10000"/>
               </a:srgbClr>
             </a:outerShdw>
           </a:effectLst>
@@ -24498,9 +24498,9 @@
             <a:prstDash val="solid"/>
           </a:ln>
           <a:effectLst>
-            <a:outerShdw sx="100000" sy="100000" kx="0" ky="0" algn="bl" rotWithShape="0" blurRad="Infinity" dist="Infinity" dir="Infinity">
+            <a:outerShdw sx="100000" sy="100000" kx="0" ky="0" algn="bl" rotWithShape="0" blurRad="101600" dist="25400" dir="5400000">
               <a:srgbClr val="1B2A4A">
-                <a:alpha val="Infinity"/>
+                <a:alpha val="10000"/>
               </a:srgbClr>
             </a:outerShdw>
           </a:effectLst>
@@ -24610,9 +24610,9 @@
             <a:prstDash val="solid"/>
           </a:ln>
           <a:effectLst>
-            <a:outerShdw sx="100000" sy="100000" kx="0" ky="0" algn="bl" rotWithShape="0" blurRad="Infinity" dist="Infinity" dir="Infinity">
+            <a:outerShdw sx="100000" sy="100000" kx="0" ky="0" algn="bl" rotWithShape="0" blurRad="101600" dist="25400" dir="5400000">
               <a:srgbClr val="1B2A4A">
-                <a:alpha val="Infinity"/>
+                <a:alpha val="10000"/>
               </a:srgbClr>
             </a:outerShdw>
           </a:effectLst>
@@ -24722,9 +24722,9 @@
             <a:prstDash val="solid"/>
           </a:ln>
           <a:effectLst>
-            <a:outerShdw sx="100000" sy="100000" kx="0" ky="0" algn="bl" rotWithShape="0" blurRad="Infinity" dist="Infinity" dir="Infinity">
+            <a:outerShdw sx="100000" sy="100000" kx="0" ky="0" algn="bl" rotWithShape="0" blurRad="101600" dist="25400" dir="5400000">
               <a:srgbClr val="1B2A4A">
-                <a:alpha val="Infinity"/>
+                <a:alpha val="10000"/>
               </a:srgbClr>
             </a:outerShdw>
           </a:effectLst>
@@ -25176,9 +25176,9 @@
             <a:prstDash val="solid"/>
           </a:ln>
           <a:effectLst>
-            <a:outerShdw sx="100000" sy="100000" kx="0" ky="0" algn="bl" rotWithShape="0" blurRad="Infinity" dist="Infinity" dir="Infinity">
+            <a:outerShdw sx="100000" sy="100000" kx="0" ky="0" algn="bl" rotWithShape="0" blurRad="101600" dist="25400" dir="5400000">
               <a:srgbClr val="1B2A4A">
-                <a:alpha val="Infinity"/>
+                <a:alpha val="10000"/>
               </a:srgbClr>
             </a:outerShdw>
           </a:effectLst>
@@ -25384,9 +25384,9 @@
             <a:prstDash val="solid"/>
           </a:ln>
           <a:effectLst>
-            <a:outerShdw sx="100000" sy="100000" kx="0" ky="0" algn="bl" rotWithShape="0" blurRad="Infinity" dist="Infinity" dir="Infinity">
+            <a:outerShdw sx="100000" sy="100000" kx="0" ky="0" algn="bl" rotWithShape="0" blurRad="101600" dist="25400" dir="5400000">
               <a:srgbClr val="1B2A4A">
-                <a:alpha val="Infinity"/>
+                <a:alpha val="10000"/>
               </a:srgbClr>
             </a:outerShdw>
           </a:effectLst>
@@ -25496,9 +25496,9 @@
             <a:prstDash val="solid"/>
           </a:ln>
           <a:effectLst>
-            <a:outerShdw sx="100000" sy="100000" kx="0" ky="0" algn="bl" rotWithShape="0" blurRad="Infinity" dist="Infinity" dir="Infinity">
+            <a:outerShdw sx="100000" sy="100000" kx="0" ky="0" algn="bl" rotWithShape="0" blurRad="101600" dist="25400" dir="5400000">
               <a:srgbClr val="1B2A4A">
-                <a:alpha val="Infinity"/>
+                <a:alpha val="10000"/>
               </a:srgbClr>
             </a:outerShdw>
           </a:effectLst>
@@ -25608,9 +25608,9 @@
             <a:prstDash val="solid"/>
           </a:ln>
           <a:effectLst>
-            <a:outerShdw sx="100000" sy="100000" kx="0" ky="0" algn="bl" rotWithShape="0" blurRad="Infinity" dist="Infinity" dir="Infinity">
+            <a:outerShdw sx="100000" sy="100000" kx="0" ky="0" algn="bl" rotWithShape="0" blurRad="101600" dist="25400" dir="5400000">
               <a:srgbClr val="1B2A4A">
-                <a:alpha val="Infinity"/>
+                <a:alpha val="10000"/>
               </a:srgbClr>
             </a:outerShdw>
           </a:effectLst>
@@ -25720,9 +25720,9 @@
             <a:prstDash val="solid"/>
           </a:ln>
           <a:effectLst>
-            <a:outerShdw sx="100000" sy="100000" kx="0" ky="0" algn="bl" rotWithShape="0" blurRad="Infinity" dist="Infinity" dir="Infinity">
+            <a:outerShdw sx="100000" sy="100000" kx="0" ky="0" algn="bl" rotWithShape="0" blurRad="101600" dist="25400" dir="5400000">
               <a:srgbClr val="1B2A4A">
-                <a:alpha val="Infinity"/>
+                <a:alpha val="10000"/>
               </a:srgbClr>
             </a:outerShdw>
           </a:effectLst>
@@ -25832,9 +25832,9 @@
             <a:prstDash val="solid"/>
           </a:ln>
           <a:effectLst>
-            <a:outerShdw sx="100000" sy="100000" kx="0" ky="0" algn="bl" rotWithShape="0" blurRad="Infinity" dist="Infinity" dir="Infinity">
+            <a:outerShdw sx="100000" sy="100000" kx="0" ky="0" algn="bl" rotWithShape="0" blurRad="101600" dist="25400" dir="5400000">
               <a:srgbClr val="1B2A4A">
-                <a:alpha val="Infinity"/>
+                <a:alpha val="10000"/>
               </a:srgbClr>
             </a:outerShdw>
           </a:effectLst>
@@ -25944,9 +25944,9 @@
             <a:prstDash val="solid"/>
           </a:ln>
           <a:effectLst>
-            <a:outerShdw sx="100000" sy="100000" kx="0" ky="0" algn="bl" rotWithShape="0" blurRad="Infinity" dist="Infinity" dir="Infinity">
+            <a:outerShdw sx="100000" sy="100000" kx="0" ky="0" algn="bl" rotWithShape="0" blurRad="101600" dist="25400" dir="5400000">
               <a:srgbClr val="1B2A4A">
-                <a:alpha val="Infinity"/>
+                <a:alpha val="10000"/>
               </a:srgbClr>
             </a:outerShdw>
           </a:effectLst>
@@ -26056,9 +26056,9 @@
             <a:prstDash val="solid"/>
           </a:ln>
           <a:effectLst>
-            <a:outerShdw sx="100000" sy="100000" kx="0" ky="0" algn="bl" rotWithShape="0" blurRad="Infinity" dist="Infinity" dir="Infinity">
+            <a:outerShdw sx="100000" sy="100000" kx="0" ky="0" algn="bl" rotWithShape="0" blurRad="101600" dist="25400" dir="5400000">
               <a:srgbClr val="1B2A4A">
-                <a:alpha val="Infinity"/>
+                <a:alpha val="10000"/>
               </a:srgbClr>
             </a:outerShdw>
           </a:effectLst>
@@ -26168,9 +26168,9 @@
             <a:prstDash val="solid"/>
           </a:ln>
           <a:effectLst>
-            <a:outerShdw sx="100000" sy="100000" kx="0" ky="0" algn="bl" rotWithShape="0" blurRad="Infinity" dist="Infinity" dir="Infinity">
+            <a:outerShdw sx="100000" sy="100000" kx="0" ky="0" algn="bl" rotWithShape="0" blurRad="101600" dist="25400" dir="5400000">
               <a:srgbClr val="1B2A4A">
-                <a:alpha val="Infinity"/>
+                <a:alpha val="10000"/>
               </a:srgbClr>
             </a:outerShdw>
           </a:effectLst>
@@ -26661,9 +26661,9 @@
             <a:prstDash val="solid"/>
           </a:ln>
           <a:effectLst>
-            <a:outerShdw sx="100000" sy="100000" kx="0" ky="0" algn="bl" rotWithShape="0" blurRad="5.41401873928151e+33" dist="1.3535046848203775e+33" dir="1.5116544e+40">
+            <a:outerShdw sx="100000" sy="100000" kx="0" ky="0" algn="bl" rotWithShape="0" blurRad="101600" dist="25400" dir="5400000">
               <a:srgbClr val="1B2A4A">
-                <a:alpha val="1e+39"/>
+                <a:alpha val="10000"/>
               </a:srgbClr>
             </a:outerShdw>
           </a:effectLst>
@@ -26862,9 +26862,9 @@
             <a:prstDash val="solid"/>
           </a:ln>
           <a:effectLst>
-            <a:outerShdw sx="100000" sy="100000" kx="0" ky="0" algn="bl" rotWithShape="0" blurRad="6.875803798887518e+37" dist="1.7189509497218795e+37" dir="9.069926400000001e+44">
+            <a:outerShdw sx="100000" sy="100000" kx="0" ky="0" algn="bl" rotWithShape="0" blurRad="101600" dist="25400" dir="5400000">
               <a:srgbClr val="1B2A4A">
-                <a:alpha val="9.999999999999999e+43"/>
+                <a:alpha val="10000"/>
               </a:srgbClr>
             </a:outerShdw>
           </a:effectLst>
@@ -27063,9 +27063,9 @@
             <a:prstDash val="solid"/>
           </a:ln>
           <a:effectLst>
-            <a:outerShdw sx="100000" sy="100000" kx="0" ky="0" algn="bl" rotWithShape="0" blurRad="8.732270824587148e+41" dist="2.183067706146787e+41" dir="5.44195584e+49">
+            <a:outerShdw sx="100000" sy="100000" kx="0" ky="0" algn="bl" rotWithShape="0" blurRad="101600" dist="25400" dir="5400000">
               <a:srgbClr val="1B2A4A">
-                <a:alpha val="1e+49"/>
+                <a:alpha val="10000"/>
               </a:srgbClr>
             </a:outerShdw>
           </a:effectLst>
@@ -27264,9 +27264,9 @@
             <a:prstDash val="solid"/>
           </a:ln>
           <a:effectLst>
-            <a:outerShdw sx="100000" sy="100000" kx="0" ky="0" algn="bl" rotWithShape="0" blurRad="1.1089983947225678e+46" dist="2.7724959868064195e+45" dir="3.2651735040000005e+54">
+            <a:outerShdw sx="100000" sy="100000" kx="0" ky="0" algn="bl" rotWithShape="0" blurRad="101600" dist="25400" dir="5400000">
               <a:srgbClr val="1B2A4A">
-                <a:alpha val="9.999999999999999e+53"/>
+                <a:alpha val="10000"/>
               </a:srgbClr>
             </a:outerShdw>
           </a:effectLst>
@@ -27465,9 +27465,9 @@
             <a:prstDash val="solid"/>
           </a:ln>
           <a:effectLst>
-            <a:outerShdw sx="100000" sy="100000" kx="0" ky="0" algn="bl" rotWithShape="0" blurRad="1.408427961297661e+50" dist="3.5210699032441527e+49" dir="1.9591041024000004e+59">
+            <a:outerShdw sx="100000" sy="100000" kx="0" ky="0" algn="bl" rotWithShape="0" blurRad="101600" dist="25400" dir="5400000">
               <a:srgbClr val="1B2A4A">
-                <a:alpha val="9.999999999999999e+58"/>
+                <a:alpha val="10000"/>
               </a:srgbClr>
             </a:outerShdw>
           </a:effectLst>
@@ -27880,9 +27880,9 @@
             <a:prstDash val="solid"/>
           </a:ln>
           <a:effectLst>
-            <a:outerShdw sx="100000" sy="100000" kx="0" ky="0" algn="bl" rotWithShape="0" blurRad="1.7887035108480297e+54" dist="4.471758777120074e+53" dir="1.1754624614400003e+64">
+            <a:outerShdw sx="100000" sy="100000" kx="0" ky="0" algn="bl" rotWithShape="0" blurRad="101600" dist="25400" dir="5400000">
               <a:srgbClr val="1B2A4A">
-                <a:alpha val="9.999999999999999e+63"/>
+                <a:alpha val="10000"/>
               </a:srgbClr>
             </a:outerShdw>
           </a:effectLst>
@@ -28056,9 +28056,9 @@
             <a:prstDash val="solid"/>
           </a:ln>
           <a:effectLst>
-            <a:outerShdw sx="100000" sy="100000" kx="0" ky="0" algn="bl" rotWithShape="0" blurRad="2.2716534587769977e+58" dist="5.679133646942494e+57" dir="7.052774768640002e+68">
+            <a:outerShdw sx="100000" sy="100000" kx="0" ky="0" algn="bl" rotWithShape="0" blurRad="101600" dist="25400" dir="5400000">
               <a:srgbClr val="1B2A4A">
-                <a:alpha val="9.999999999999999e+68"/>
+                <a:alpha val="10000"/>
               </a:srgbClr>
             </a:outerShdw>
           </a:effectLst>
@@ -28232,9 +28232,9 @@
             <a:prstDash val="solid"/>
           </a:ln>
           <a:effectLst>
-            <a:outerShdw sx="100000" sy="100000" kx="0" ky="0" algn="bl" rotWithShape="0" blurRad="2.8849998926467873e+62" dist="7.212499731616968e+61" dir="4.2316648611840007e+73">
+            <a:outerShdw sx="100000" sy="100000" kx="0" ky="0" algn="bl" rotWithShape="0" blurRad="101600" dist="25400" dir="5400000">
               <a:srgbClr val="1B2A4A">
-                <a:alpha val="9.999999999999998e+73"/>
+                <a:alpha val="10000"/>
               </a:srgbClr>
             </a:outerShdw>
           </a:effectLst>
@@ -28408,9 +28408,9 @@
             <a:prstDash val="solid"/>
           </a:ln>
           <a:effectLst>
-            <a:outerShdw sx="100000" sy="100000" kx="0" ky="0" algn="bl" rotWithShape="0" blurRad="3.66394986366142e+66" dist="9.15987465915355e+65" dir="2.5389989167104004e+78">
+            <a:outerShdw sx="100000" sy="100000" kx="0" ky="0" algn="bl" rotWithShape="0" blurRad="101600" dist="25400" dir="5400000">
               <a:srgbClr val="1B2A4A">
-                <a:alpha val="9.999999999999998e+78"/>
+                <a:alpha val="10000"/>
               </a:srgbClr>
             </a:outerShdw>
           </a:effectLst>
@@ -28823,9 +28823,9 @@
             <a:prstDash val="solid"/>
           </a:ln>
           <a:effectLst>
-            <a:outerShdw sx="100000" sy="100000" kx="0" ky="0" algn="bl" rotWithShape="0" blurRad="4.653216326850003e+70" dist="1.1633040817125008e+70" dir="1.5233993500262402e+83">
+            <a:outerShdw sx="100000" sy="100000" kx="0" ky="0" algn="bl" rotWithShape="0" blurRad="101600" dist="25400" dir="5400000">
               <a:srgbClr val="1B2A4A">
-                <a:alpha val="9.999999999999998e+83"/>
+                <a:alpha val="10000"/>
               </a:srgbClr>
             </a:outerShdw>
           </a:effectLst>
@@ -29040,9 +29040,9 @@
             <a:prstDash val="solid"/>
           </a:ln>
           <a:effectLst>
-            <a:outerShdw sx="100000" sy="100000" kx="0" ky="0" algn="bl" rotWithShape="0" blurRad="5.909584735099504e+74" dist="1.477396183774876e+74" dir="9.14039610015744e+87">
+            <a:outerShdw sx="100000" sy="100000" kx="0" ky="0" algn="bl" rotWithShape="0" blurRad="101600" dist="25400" dir="5400000">
               <a:srgbClr val="1B2A4A">
-                <a:alpha val="9.999999999999999e+88"/>
+                <a:alpha val="10000"/>
               </a:srgbClr>
             </a:outerShdw>
           </a:effectLst>
@@ -29257,9 +29257,9 @@
             <a:prstDash val="solid"/>
           </a:ln>
           <a:effectLst>
-            <a:outerShdw sx="100000" sy="100000" kx="0" ky="0" algn="bl" rotWithShape="0" blurRad="7.50517261357637e+78" dist="1.8762931533940924e+78" dir="5.484237660094465e+92">
+            <a:outerShdw sx="100000" sy="100000" kx="0" ky="0" algn="bl" rotWithShape="0" blurRad="101600" dist="25400" dir="5400000">
               <a:srgbClr val="1B2A4A">
-                <a:alpha val="9.999999999999998e+93"/>
+                <a:alpha val="10000"/>
               </a:srgbClr>
             </a:outerShdw>
           </a:effectLst>
@@ -29474,9 +29474,9 @@
             <a:prstDash val="solid"/>
           </a:ln>
           <a:effectLst>
-            <a:outerShdw sx="100000" sy="100000" kx="0" ky="0" algn="bl" rotWithShape="0" blurRad="9.53156921924199e+82" dist="2.3828923048104974e+82" dir="3.2905425960566786e+97">
+            <a:outerShdw sx="100000" sy="100000" kx="0" ky="0" algn="bl" rotWithShape="0" blurRad="101600" dist="25400" dir="5400000">
               <a:srgbClr val="1B2A4A">
-                <a:alpha val="9.999999999999998e+98"/>
+                <a:alpha val="10000"/>
               </a:srgbClr>
             </a:outerShdw>
           </a:effectLst>
@@ -29652,9 +29652,9 @@
             <a:prstDash val="solid"/>
           </a:ln>
           <a:effectLst>
-            <a:outerShdw sx="100000" sy="100000" kx="0" ky="0" algn="bl" rotWithShape="0" blurRad="1.2105092908437327e+87" dist="3.0262732271093317e+86" dir="1.9743255576340073e+102">
+            <a:outerShdw sx="100000" sy="100000" kx="0" ky="0" algn="bl" rotWithShape="0" blurRad="101600" dist="25400" dir="5400000">
               <a:srgbClr val="1B2A4A">
-                <a:alpha val="9.999999999999998e+103"/>
+                <a:alpha val="10000"/>
               </a:srgbClr>
             </a:outerShdw>
           </a:effectLst>
@@ -30067,9 +30067,9 @@
             <a:prstDash val="solid"/>
           </a:ln>
           <a:effectLst>
-            <a:outerShdw sx="100000" sy="100000" kx="0" ky="0" algn="bl" rotWithShape="0" blurRad="1.5373467993715405e+91" dist="3.8433669984288512e+90" dir="1.1845953345804043e+107">
+            <a:outerShdw sx="100000" sy="100000" kx="0" ky="0" algn="bl" rotWithShape="0" blurRad="101600" dist="25400" dir="5400000">
               <a:srgbClr val="1B2A4A">
-                <a:alpha val="9.999999999999998e+108"/>
+                <a:alpha val="10000"/>
               </a:srgbClr>
             </a:outerShdw>
           </a:effectLst>
@@ -30250,9 +30250,9 @@
             <a:prstDash val="solid"/>
           </a:ln>
           <a:effectLst>
-            <a:outerShdw sx="100000" sy="100000" kx="0" ky="0" algn="bl" rotWithShape="0" blurRad="1.9524304352018566e+95" dist="4.8810760880046414e+94" dir="7.107572007482426e+111">
+            <a:outerShdw sx="100000" sy="100000" kx="0" ky="0" algn="bl" rotWithShape="0" blurRad="101600" dist="25400" dir="5400000">
               <a:srgbClr val="1B2A4A">
-                <a:alpha val="9.999999999999997e+113"/>
+                <a:alpha val="10000"/>
               </a:srgbClr>
             </a:outerShdw>
           </a:effectLst>
@@ -30475,9 +30475,9 @@
             <a:prstDash val="solid"/>
           </a:ln>
           <a:effectLst>
-            <a:outerShdw sx="100000" sy="100000" kx="0" ky="0" algn="bl" rotWithShape="0" blurRad="2.4795866527063578e+99" dist="6.198966631765894e+98" dir="4.2645432044894554e+116">
+            <a:outerShdw sx="100000" sy="100000" kx="0" ky="0" algn="bl" rotWithShape="0" blurRad="101600" dist="25400" dir="5400000">
               <a:srgbClr val="1B2A4A">
-                <a:alpha val="9.999999999999998e+118"/>
+                <a:alpha val="10000"/>
               </a:srgbClr>
             </a:outerShdw>
           </a:effectLst>
@@ -31021,9 +31021,9 @@
             <a:prstDash val="solid"/>
           </a:ln>
           <a:effectLst>
-            <a:outerShdw sx="100000" sy="100000" kx="0" ky="0" algn="bl" rotWithShape="0" blurRad="3.149075048937074e+103" dist="7.872687622342685e+102" dir="2.5587259226936733e+121">
+            <a:outerShdw sx="100000" sy="100000" kx="0" ky="0" algn="bl" rotWithShape="0" blurRad="101600" dist="25400" dir="5400000">
               <a:srgbClr val="1B2A4A">
-                <a:alpha val="9.999999999999997e+123"/>
+                <a:alpha val="10000"/>
               </a:srgbClr>
             </a:outerShdw>
           </a:effectLst>
@@ -31133,9 +31133,9 @@
             <a:prstDash val="solid"/>
           </a:ln>
           <a:effectLst>
-            <a:outerShdw sx="100000" sy="100000" kx="0" ky="0" algn="bl" rotWithShape="0" blurRad="3.9993253121500844e+107" dist="9.998313280375211e+106" dir="1.535235553616204e+126">
+            <a:outerShdw sx="100000" sy="100000" kx="0" ky="0" algn="bl" rotWithShape="0" blurRad="101600" dist="25400" dir="5400000">
               <a:srgbClr val="1B2A4A">
-                <a:alpha val="9.999999999999997e+128"/>
+                <a:alpha val="10000"/>
               </a:srgbClr>
             </a:outerShdw>
           </a:effectLst>
@@ -31245,9 +31245,9 @@
             <a:prstDash val="solid"/>
           </a:ln>
           <a:effectLst>
-            <a:outerShdw sx="100000" sy="100000" kx="0" ky="0" algn="bl" rotWithShape="0" blurRad="5.079143146430607e+111" dist="1.2697857866076517e+111" dir="9.211413321697224e+130">
+            <a:outerShdw sx="100000" sy="100000" kx="0" ky="0" algn="bl" rotWithShape="0" blurRad="101600" dist="25400" dir="5400000">
               <a:srgbClr val="1B2A4A">
-                <a:alpha val="9.999999999999997e+133"/>
+                <a:alpha val="10000"/>
               </a:srgbClr>
             </a:outerShdw>
           </a:effectLst>
@@ -31357,9 +31357,9 @@
             <a:prstDash val="solid"/>
           </a:ln>
           <a:effectLst>
-            <a:outerShdw sx="100000" sy="100000" kx="0" ky="0" algn="bl" rotWithShape="0" blurRad="6.450511795966871e+115" dist="1.6126279489917177e+115" dir="5.526847993018334e+135">
+            <a:outerShdw sx="100000" sy="100000" kx="0" ky="0" algn="bl" rotWithShape="0" blurRad="101600" dist="25400" dir="5400000">
               <a:srgbClr val="1B2A4A">
-                <a:alpha val="9.999999999999998e+138"/>
+                <a:alpha val="10000"/>
               </a:srgbClr>
             </a:outerShdw>
           </a:effectLst>
@@ -31469,9 +31469,9 @@
             <a:prstDash val="solid"/>
           </a:ln>
           <a:effectLst>
-            <a:outerShdw sx="100000" sy="100000" kx="0" ky="0" algn="bl" rotWithShape="0" blurRad="8.192149980877925e+119" dist="2.0480374952194813e+119" dir="3.3161087958110005e+140">
+            <a:outerShdw sx="100000" sy="100000" kx="0" ky="0" algn="bl" rotWithShape="0" blurRad="101600" dist="25400" dir="5400000">
               <a:srgbClr val="1B2A4A">
-                <a:alpha val="9.999999999999999e+143"/>
+                <a:alpha val="10000"/>
               </a:srgbClr>
             </a:outerShdw>
           </a:effectLst>
@@ -31581,9 +31581,9 @@
             <a:prstDash val="solid"/>
           </a:ln>
           <a:effectLst>
-            <a:outerShdw sx="100000" sy="100000" kx="0" ky="0" algn="bl" rotWithShape="0" blurRad="1.0404030475714965e+124" dist="2.6010076189287412e+123" dir="1.9896652774866004e+145">
+            <a:outerShdw sx="100000" sy="100000" kx="0" ky="0" algn="bl" rotWithShape="0" blurRad="101600" dist="25400" dir="5400000">
               <a:srgbClr val="1B2A4A">
-                <a:alpha val="9.999999999999998e+148"/>
+                <a:alpha val="10000"/>
               </a:srgbClr>
             </a:outerShdw>
           </a:effectLst>
@@ -31693,9 +31693,9 @@
             <a:prstDash val="solid"/>
           </a:ln>
           <a:effectLst>
-            <a:outerShdw sx="100000" sy="100000" kx="0" ky="0" algn="bl" rotWithShape="0" blurRad="1.3213118704158005e+128" dist="3.303279676039501e+127" dir="1.1937991664919603e+150">
+            <a:outerShdw sx="100000" sy="100000" kx="0" ky="0" algn="bl" rotWithShape="0" blurRad="101600" dist="25400" dir="5400000">
               <a:srgbClr val="1B2A4A">
-                <a:alpha val="9.999999999999999e+153"/>
+                <a:alpha val="10000"/>
               </a:srgbClr>
             </a:outerShdw>
           </a:effectLst>
@@ -32108,9 +32108,9 @@
             <a:prstDash val="solid"/>
           </a:ln>
           <a:effectLst>
-            <a:outerShdw sx="100000" sy="100000" kx="0" ky="0" algn="bl" rotWithShape="0" blurRad="1.6780660754280665e+132" dist="4.195165188570166e+131" dir="7.162794998951762e+154">
+            <a:outerShdw sx="100000" sy="100000" kx="0" ky="0" algn="bl" rotWithShape="0" blurRad="101600" dist="25400" dir="5400000">
               <a:srgbClr val="1B2A4A">
-                <a:alpha val="1e+159"/>
+                <a:alpha val="10000"/>
               </a:srgbClr>
             </a:outerShdw>
           </a:effectLst>
@@ -32350,9 +32350,9 @@
             <a:prstDash val="solid"/>
           </a:ln>
           <a:effectLst>
-            <a:outerShdw sx="100000" sy="100000" kx="0" ky="0" algn="bl" rotWithShape="0" blurRad="2.1311439157936445e+136" dist="5.327859789484111e+135" dir="4.297676999371057e+159">
+            <a:outerShdw sx="100000" sy="100000" kx="0" ky="0" algn="bl" rotWithShape="0" blurRad="101600" dist="25400" dir="5400000">
               <a:srgbClr val="1B2A4A">
-                <a:alpha val="9.999999999999999e+163"/>
+                <a:alpha val="10000"/>
               </a:srgbClr>
             </a:outerShdw>
           </a:effectLst>
@@ -32550,9 +32550,9 @@
             <a:prstDash val="solid"/>
           </a:ln>
           <a:effectLst>
-            <a:outerShdw sx="100000" sy="100000" kx="0" ky="0" algn="bl" rotWithShape="0" blurRad="2.7065527730579285e+140" dist="6.766381932644821e+139" dir="2.5786061996226343e+164">
+            <a:outerShdw sx="100000" sy="100000" kx="0" ky="0" algn="bl" rotWithShape="0" blurRad="101600" dist="25400" dir="5400000">
               <a:srgbClr val="1B2A4A">
-                <a:alpha val="1e+169"/>
+                <a:alpha val="10000"/>
               </a:srgbClr>
             </a:outerShdw>
           </a:effectLst>
@@ -33092,9 +33092,9 @@
             <a:prstDash val="solid"/>
           </a:ln>
           <a:effectLst>
-            <a:outerShdw sx="100000" sy="100000" kx="0" ky="0" algn="bl" rotWithShape="0" blurRad="3.4373220217835694e+144" dist="8.593305054458923e+143" dir="1.5471637197735807e+169">
+            <a:outerShdw sx="100000" sy="100000" kx="0" ky="0" algn="bl" rotWithShape="0" blurRad="101600" dist="25400" dir="5400000">
               <a:srgbClr val="1B2A4A">
-                <a:alpha val="9.999999999999998e+173"/>
+                <a:alpha val="10000"/>
               </a:srgbClr>
             </a:outerShdw>
           </a:effectLst>
@@ -33307,9 +33307,9 @@
             <a:prstDash val="solid"/>
           </a:ln>
           <a:effectLst>
-            <a:outerShdw sx="100000" sy="100000" kx="0" ky="0" algn="bl" rotWithShape="0" blurRad="4.3653989676651333e+148" dist="1.0913497419162833e+148" dir="9.282982318641485e+173">
+            <a:outerShdw sx="100000" sy="100000" kx="0" ky="0" algn="bl" rotWithShape="0" blurRad="101600" dist="25400" dir="5400000">
               <a:srgbClr val="1B2A4A">
-                <a:alpha val="9.999999999999998e+178"/>
+                <a:alpha val="10000"/>
               </a:srgbClr>
             </a:outerShdw>
           </a:effectLst>
@@ -33522,9 +33522,9 @@
             <a:prstDash val="solid"/>
           </a:ln>
           <a:effectLst>
-            <a:outerShdw sx="100000" sy="100000" kx="0" ky="0" algn="bl" rotWithShape="0" blurRad="5.54405668893472e+152" dist="1.38601417223368e+152" dir="5.569789391184891e+178">
+            <a:outerShdw sx="100000" sy="100000" kx="0" ky="0" algn="bl" rotWithShape="0" blurRad="101600" dist="25400" dir="5400000">
               <a:srgbClr val="1B2A4A">
-                <a:alpha val="9.999999999999998e+183"/>
+                <a:alpha val="10000"/>
               </a:srgbClr>
             </a:outerShdw>
           </a:effectLst>
@@ -33698,9 +33698,9 @@
             <a:prstDash val="solid"/>
           </a:ln>
           <a:effectLst>
-            <a:outerShdw sx="100000" sy="100000" kx="0" ky="0" algn="bl" rotWithShape="0" blurRad="7.040951994947093e+156" dist="1.7602379987367734e+156" dir="3.3418736347109347e+183">
+            <a:outerShdw sx="100000" sy="100000" kx="0" ky="0" algn="bl" rotWithShape="0" blurRad="101600" dist="25400" dir="5400000">
               <a:srgbClr val="1B2A4A">
-                <a:alpha val="9.999999999999998e+188"/>
+                <a:alpha val="10000"/>
               </a:srgbClr>
             </a:outerShdw>
           </a:effectLst>
@@ -33913,9 +33913,9 @@
             <a:prstDash val="solid"/>
           </a:ln>
           <a:effectLst>
-            <a:outerShdw sx="100000" sy="100000" kx="0" ky="0" algn="bl" rotWithShape="0" blurRad="8.942009033582808e+160" dist="2.235502258395702e+160" dir="2.0051241808265608e+188">
+            <a:outerShdw sx="100000" sy="100000" kx="0" ky="0" algn="bl" rotWithShape="0" blurRad="101600" dist="25400" dir="5400000">
               <a:srgbClr val="1B2A4A">
-                <a:alpha val="9.999999999999998e+193"/>
+                <a:alpha val="10000"/>
               </a:srgbClr>
             </a:outerShdw>
           </a:effectLst>
@@ -34128,9 +34128,9 @@
             <a:prstDash val="solid"/>
           </a:ln>
           <a:effectLst>
-            <a:outerShdw sx="100000" sy="100000" kx="0" ky="0" algn="bl" rotWithShape="0" blurRad="1.1356351472650167e+165" dist="2.8390878681625417e+164" dir="1.2030745084959364e+193">
+            <a:outerShdw sx="100000" sy="100000" kx="0" ky="0" algn="bl" rotWithShape="0" blurRad="101600" dist="25400" dir="5400000">
               <a:srgbClr val="1B2A4A">
-                <a:alpha val="9.999999999999999e+198"/>
+                <a:alpha val="10000"/>
               </a:srgbClr>
             </a:outerShdw>
           </a:effectLst>

</xml_diff>

<commit_message>
docs(deck): explain each pilot target on slide 5
Co-Authored-By: Claude Sonnet 5.5 <noreply@anthropic.com>
</commit_message>
<xml_diff>
--- a/POS-Merchant-Hunter_Presentasi-Manajemen.pptx
+++ b/POS-Merchant-Hunter_Presentasi-Manajemen.pptx
@@ -28457,12 +28457,12 @@
         </p:nvSpPr>
         <p:spPr>
           <a:xfrm>
-            <a:off x="548640" y="1645920"/>
-            <a:ext cx="3566160" cy="2103120"/>
+            <a:off x="548640" y="1554480"/>
+            <a:ext cx="3566160" cy="2057400"/>
           </a:xfrm>
           <a:prstGeom prst="roundRect">
             <a:avLst>
-              <a:gd name="adj" fmla="val 3478"/>
+              <a:gd name="adj" fmla="val 3556"/>
             </a:avLst>
           </a:prstGeom>
           <a:solidFill>
@@ -28491,8 +28491,8 @@
         </p:nvSpPr>
         <p:spPr>
           <a:xfrm>
-            <a:off x="822960" y="1828800"/>
-            <a:ext cx="3017520" cy="1097280"/>
+            <a:off x="822960" y="1664208"/>
+            <a:ext cx="3017520" cy="777240"/>
           </a:xfrm>
           <a:prstGeom prst="rect">
             <a:avLst/>
@@ -28508,7 +28508,7 @@
               <a:buNone/>
             </a:pPr>
             <a:r>
-              <a:rPr lang="en-US" sz="5400" b="1" dirty="0">
+              <a:rPr lang="en-US" sz="4400" b="1" dirty="0">
                 <a:solidFill>
                   <a:srgbClr val="D9481C"/>
                 </a:solidFill>
@@ -28518,7 +28518,7 @@
               </a:rPr>
               <a:t>≥ 25</a:t>
             </a:r>
-            <a:endParaRPr lang="en-US" sz="5400" dirty="0"/>
+            <a:endParaRPr lang="en-US" sz="4400" dirty="0"/>
           </a:p>
         </p:txBody>
       </p:sp>
@@ -28530,8 +28530,8 @@
         </p:nvSpPr>
         <p:spPr>
           <a:xfrm>
-            <a:off x="822960" y="3017520"/>
-            <a:ext cx="3017520" cy="640080"/>
+            <a:off x="822960" y="2468880"/>
+            <a:ext cx="3017520" cy="365760"/>
           </a:xfrm>
           <a:prstGeom prst="rect">
             <a:avLst/>
@@ -28547,7 +28547,46 @@
               <a:buNone/>
             </a:pPr>
             <a:r>
-              <a:rPr lang="en-US" sz="1800" dirty="0">
+              <a:rPr lang="en-US" sz="2000" b="1" dirty="0">
+                <a:solidFill>
+                  <a:srgbClr val="14213D"/>
+                </a:solidFill>
+                <a:latin typeface="Arial" pitchFamily="34" charset="0"/>
+                <a:ea typeface="Arial" pitchFamily="34" charset="-122"/>
+                <a:cs typeface="Arial" pitchFamily="34" charset="-120"/>
+              </a:rPr>
+              <a:t>Calon aktif per outlet</a:t>
+            </a:r>
+            <a:endParaRPr lang="en-US" sz="2000" dirty="0"/>
+          </a:p>
+        </p:txBody>
+      </p:sp>
+      <p:sp>
+        <p:nvSpPr>
+          <p:cNvPr id="13" name="Text 10"/>
+          <p:cNvSpPr/>
+          <p:nvPr/>
+        </p:nvSpPr>
+        <p:spPr>
+          <a:xfrm>
+            <a:off x="822960" y="2880360"/>
+            <a:ext cx="3063240" cy="685800"/>
+          </a:xfrm>
+          <a:prstGeom prst="rect">
+            <a:avLst/>
+          </a:prstGeom>
+          <a:noFill/>
+          <a:ln/>
+        </p:spPr>
+        <p:txBody>
+          <a:bodyPr wrap="square" lIns="0" tIns="0" rIns="0" bIns="0" rtlCol="0" anchor="t"/>
+          <a:lstStyle/>
+          <a:p>
+            <a:pPr algn="l" indent="0" marL="0">
+              <a:buNone/>
+            </a:pPr>
+            <a:r>
+              <a:rPr lang="en-US" sz="1500" dirty="0">
                 <a:solidFill>
                   <a:srgbClr val="4F5A70"/>
                 </a:solidFill>
@@ -28555,26 +28594,26 @@
                 <a:ea typeface="Arial" pitchFamily="34" charset="-122"/>
                 <a:cs typeface="Arial" pitchFamily="34" charset="-120"/>
               </a:rPr>
-              <a:t>calon per outlet</a:t>
+              <a:t>Tiap outlet punya minimal 25 calon unik yang layak dihubungi.</a:t>
             </a:r>
-            <a:endParaRPr lang="en-US" sz="1800" dirty="0"/>
+            <a:endParaRPr lang="en-US" sz="1500" dirty="0"/>
           </a:p>
         </p:txBody>
       </p:sp>
       <p:sp>
         <p:nvSpPr>
-          <p:cNvPr id="13" name="Shape 10"/>
-          <p:cNvSpPr/>
-          <p:nvPr/>
-        </p:nvSpPr>
-        <p:spPr>
-          <a:xfrm>
-            <a:off x="4297680" y="1645920"/>
-            <a:ext cx="3566160" cy="2103120"/>
+          <p:cNvPr id="14" name="Shape 11"/>
+          <p:cNvSpPr/>
+          <p:nvPr/>
+        </p:nvSpPr>
+        <p:spPr>
+          <a:xfrm>
+            <a:off x="4297680" y="1554480"/>
+            <a:ext cx="3566160" cy="2057400"/>
           </a:xfrm>
           <a:prstGeom prst="roundRect">
             <a:avLst>
-              <a:gd name="adj" fmla="val 3478"/>
+              <a:gd name="adj" fmla="val 3556"/>
             </a:avLst>
           </a:prstGeom>
           <a:solidFill>
@@ -28597,14 +28636,14 @@
       </p:sp>
       <p:sp>
         <p:nvSpPr>
-          <p:cNvPr id="14" name="Text 11"/>
-          <p:cNvSpPr/>
-          <p:nvPr/>
-        </p:nvSpPr>
-        <p:spPr>
-          <a:xfrm>
-            <a:off x="4572000" y="1828800"/>
-            <a:ext cx="3017520" cy="1097280"/>
+          <p:cNvPr id="15" name="Text 12"/>
+          <p:cNvSpPr/>
+          <p:nvPr/>
+        </p:nvSpPr>
+        <p:spPr>
+          <a:xfrm>
+            <a:off x="4572000" y="1664208"/>
+            <a:ext cx="3017520" cy="777240"/>
           </a:xfrm>
           <a:prstGeom prst="rect">
             <a:avLst/>
@@ -28620,7 +28659,7 @@
               <a:buNone/>
             </a:pPr>
             <a:r>
-              <a:rPr lang="en-US" sz="5400" b="1" dirty="0">
+              <a:rPr lang="en-US" sz="4400" b="1" dirty="0">
                 <a:solidFill>
                   <a:srgbClr val="0F7A6E"/>
                 </a:solidFill>
@@ -28630,20 +28669,20 @@
               </a:rPr>
               <a:t>−50%</a:t>
             </a:r>
-            <a:endParaRPr lang="en-US" sz="5400" dirty="0"/>
+            <a:endParaRPr lang="en-US" sz="4400" dirty="0"/>
           </a:p>
         </p:txBody>
       </p:sp>
       <p:sp>
         <p:nvSpPr>
-          <p:cNvPr id="15" name="Text 12"/>
-          <p:cNvSpPr/>
-          <p:nvPr/>
-        </p:nvSpPr>
-        <p:spPr>
-          <a:xfrm>
-            <a:off x="4572000" y="3017520"/>
-            <a:ext cx="3017520" cy="640080"/>
+          <p:cNvPr id="16" name="Text 13"/>
+          <p:cNvSpPr/>
+          <p:nvPr/>
+        </p:nvSpPr>
+        <p:spPr>
+          <a:xfrm>
+            <a:off x="4572000" y="2468880"/>
+            <a:ext cx="3017520" cy="365760"/>
           </a:xfrm>
           <a:prstGeom prst="rect">
             <a:avLst/>
@@ -28659,7 +28698,46 @@
               <a:buNone/>
             </a:pPr>
             <a:r>
-              <a:rPr lang="en-US" sz="1800" dirty="0">
+              <a:rPr lang="en-US" sz="2000" b="1" dirty="0">
+                <a:solidFill>
+                  <a:srgbClr val="14213D"/>
+                </a:solidFill>
+                <a:latin typeface="Arial" pitchFamily="34" charset="0"/>
+                <a:ea typeface="Arial" pitchFamily="34" charset="-122"/>
+                <a:cs typeface="Arial" pitchFamily="34" charset="-120"/>
+              </a:rPr>
+              <a:t>Waktu riset sales</a:t>
+            </a:r>
+            <a:endParaRPr lang="en-US" sz="2000" dirty="0"/>
+          </a:p>
+        </p:txBody>
+      </p:sp>
+      <p:sp>
+        <p:nvSpPr>
+          <p:cNvPr id="17" name="Text 14"/>
+          <p:cNvSpPr/>
+          <p:nvPr/>
+        </p:nvSpPr>
+        <p:spPr>
+          <a:xfrm>
+            <a:off x="4572000" y="2880360"/>
+            <a:ext cx="3063240" cy="685800"/>
+          </a:xfrm>
+          <a:prstGeom prst="rect">
+            <a:avLst/>
+          </a:prstGeom>
+          <a:noFill/>
+          <a:ln/>
+        </p:spPr>
+        <p:txBody>
+          <a:bodyPr wrap="square" lIns="0" tIns="0" rIns="0" bIns="0" rtlCol="0" anchor="t"/>
+          <a:lstStyle/>
+          <a:p>
+            <a:pPr algn="l" indent="0" marL="0">
+              <a:buNone/>
+            </a:pPr>
+            <a:r>
+              <a:rPr lang="en-US" sz="1500" dirty="0">
                 <a:solidFill>
                   <a:srgbClr val="4F5A70"/>
                 </a:solidFill>
@@ -28667,26 +28745,26 @@
                 <a:ea typeface="Arial" pitchFamily="34" charset="-122"/>
                 <a:cs typeface="Arial" pitchFamily="34" charset="-120"/>
               </a:rPr>
-              <a:t>waktu riset sales</a:t>
+              <a:t>Waktu menyusun daftar kunjungan mingguan turun separuh dari kondisi awal.</a:t>
             </a:r>
-            <a:endParaRPr lang="en-US" sz="1800" dirty="0"/>
+            <a:endParaRPr lang="en-US" sz="1500" dirty="0"/>
           </a:p>
         </p:txBody>
       </p:sp>
       <p:sp>
         <p:nvSpPr>
-          <p:cNvPr id="16" name="Shape 13"/>
-          <p:cNvSpPr/>
-          <p:nvPr/>
-        </p:nvSpPr>
-        <p:spPr>
-          <a:xfrm>
-            <a:off x="8046720" y="1645920"/>
-            <a:ext cx="3566160" cy="2103120"/>
+          <p:cNvPr id="18" name="Shape 15"/>
+          <p:cNvSpPr/>
+          <p:nvPr/>
+        </p:nvSpPr>
+        <p:spPr>
+          <a:xfrm>
+            <a:off x="8046720" y="1554480"/>
+            <a:ext cx="3566160" cy="2057400"/>
           </a:xfrm>
           <a:prstGeom prst="roundRect">
             <a:avLst>
-              <a:gd name="adj" fmla="val 3478"/>
+              <a:gd name="adj" fmla="val 3556"/>
             </a:avLst>
           </a:prstGeom>
           <a:solidFill>
@@ -28709,14 +28787,14 @@
       </p:sp>
       <p:sp>
         <p:nvSpPr>
-          <p:cNvPr id="17" name="Text 14"/>
-          <p:cNvSpPr/>
-          <p:nvPr/>
-        </p:nvSpPr>
-        <p:spPr>
-          <a:xfrm>
-            <a:off x="8321040" y="1828800"/>
-            <a:ext cx="3017520" cy="1097280"/>
+          <p:cNvPr id="19" name="Text 16"/>
+          <p:cNvSpPr/>
+          <p:nvPr/>
+        </p:nvSpPr>
+        <p:spPr>
+          <a:xfrm>
+            <a:off x="8321040" y="1664208"/>
+            <a:ext cx="3017520" cy="777240"/>
           </a:xfrm>
           <a:prstGeom prst="rect">
             <a:avLst/>
@@ -28732,7 +28810,7 @@
               <a:buNone/>
             </a:pPr>
             <a:r>
-              <a:rPr lang="en-US" sz="5400" b="1" dirty="0">
+              <a:rPr lang="en-US" sz="4400" b="1" dirty="0">
                 <a:solidFill>
                   <a:srgbClr val="A66A0A"/>
                 </a:solidFill>
@@ -28742,20 +28820,20 @@
               </a:rPr>
               <a:t>0</a:t>
             </a:r>
-            <a:endParaRPr lang="en-US" sz="5400" dirty="0"/>
+            <a:endParaRPr lang="en-US" sz="4400" dirty="0"/>
           </a:p>
         </p:txBody>
       </p:sp>
       <p:sp>
         <p:nvSpPr>
-          <p:cNvPr id="18" name="Text 15"/>
-          <p:cNvSpPr/>
-          <p:nvPr/>
-        </p:nvSpPr>
-        <p:spPr>
-          <a:xfrm>
-            <a:off x="8321040" y="3017520"/>
-            <a:ext cx="3017520" cy="640080"/>
+          <p:cNvPr id="20" name="Text 17"/>
+          <p:cNvSpPr/>
+          <p:nvPr/>
+        </p:nvSpPr>
+        <p:spPr>
+          <a:xfrm>
+            <a:off x="8321040" y="2468880"/>
+            <a:ext cx="3017520" cy="365760"/>
           </a:xfrm>
           <a:prstGeom prst="rect">
             <a:avLst/>
@@ -28771,7 +28849,46 @@
               <a:buNone/>
             </a:pPr>
             <a:r>
-              <a:rPr lang="en-US" sz="1800" dirty="0">
+              <a:rPr lang="en-US" sz="2000" b="1" dirty="0">
+                <a:solidFill>
+                  <a:srgbClr val="14213D"/>
+                </a:solidFill>
+                <a:latin typeface="Arial" pitchFamily="34" charset="0"/>
+                <a:ea typeface="Arial" pitchFamily="34" charset="-122"/>
+                <a:cs typeface="Arial" pitchFamily="34" charset="-120"/>
+              </a:rPr>
+              <a:t>Kontak ganda</a:t>
+            </a:r>
+            <a:endParaRPr lang="en-US" sz="2000" dirty="0"/>
+          </a:p>
+        </p:txBody>
+      </p:sp>
+      <p:sp>
+        <p:nvSpPr>
+          <p:cNvPr id="21" name="Text 18"/>
+          <p:cNvSpPr/>
+          <p:nvPr/>
+        </p:nvSpPr>
+        <p:spPr>
+          <a:xfrm>
+            <a:off x="8321040" y="2880360"/>
+            <a:ext cx="3063240" cy="685800"/>
+          </a:xfrm>
+          <a:prstGeom prst="rect">
+            <a:avLst/>
+          </a:prstGeom>
+          <a:noFill/>
+          <a:ln/>
+        </p:spPr>
+        <p:txBody>
+          <a:bodyPr wrap="square" lIns="0" tIns="0" rIns="0" bIns="0" rtlCol="0" anchor="t"/>
+          <a:lstStyle/>
+          <a:p>
+            <a:pPr algn="l" indent="0" marL="0">
+              <a:buNone/>
+            </a:pPr>
+            <a:r>
+              <a:rPr lang="en-US" sz="1500" dirty="0">
                 <a:solidFill>
                   <a:srgbClr val="4F5A70"/>
                 </a:solidFill>
@@ -28779,26 +28896,26 @@
                 <a:ea typeface="Arial" pitchFamily="34" charset="-122"/>
                 <a:cs typeface="Arial" pitchFamily="34" charset="-120"/>
               </a:rPr>
-              <a:t>kontak ganda tanpa peringatan</a:t>
+              <a:t>Tidak ada calon yang dihubungi dua orang tanpa peringatan di layar.</a:t>
             </a:r>
-            <a:endParaRPr lang="en-US" sz="1800" dirty="0"/>
+            <a:endParaRPr lang="en-US" sz="1500" dirty="0"/>
           </a:p>
         </p:txBody>
       </p:sp>
       <p:sp>
         <p:nvSpPr>
-          <p:cNvPr id="19" name="Shape 16"/>
-          <p:cNvSpPr/>
-          <p:nvPr/>
-        </p:nvSpPr>
-        <p:spPr>
-          <a:xfrm>
-            <a:off x="548640" y="3931920"/>
-            <a:ext cx="3566160" cy="2103120"/>
+          <p:cNvPr id="22" name="Shape 19"/>
+          <p:cNvSpPr/>
+          <p:nvPr/>
+        </p:nvSpPr>
+        <p:spPr>
+          <a:xfrm>
+            <a:off x="548640" y="3749040"/>
+            <a:ext cx="3566160" cy="2057400"/>
           </a:xfrm>
           <a:prstGeom prst="roundRect">
             <a:avLst>
-              <a:gd name="adj" fmla="val 3478"/>
+              <a:gd name="adj" fmla="val 3556"/>
             </a:avLst>
           </a:prstGeom>
           <a:solidFill>
@@ -28821,14 +28938,14 @@
       </p:sp>
       <p:sp>
         <p:nvSpPr>
-          <p:cNvPr id="20" name="Text 17"/>
-          <p:cNvSpPr/>
-          <p:nvPr/>
-        </p:nvSpPr>
-        <p:spPr>
-          <a:xfrm>
-            <a:off x="822960" y="4114800"/>
-            <a:ext cx="3017520" cy="1097280"/>
+          <p:cNvPr id="23" name="Text 20"/>
+          <p:cNvSpPr/>
+          <p:nvPr/>
+        </p:nvSpPr>
+        <p:spPr>
+          <a:xfrm>
+            <a:off x="822960" y="3858768"/>
+            <a:ext cx="3017520" cy="777240"/>
           </a:xfrm>
           <a:prstGeom prst="rect">
             <a:avLst/>
@@ -28844,7 +28961,7 @@
               <a:buNone/>
             </a:pPr>
             <a:r>
-              <a:rPr lang="en-US" sz="5400" b="1" dirty="0">
+              <a:rPr lang="en-US" sz="4400" b="1" dirty="0">
                 <a:solidFill>
                   <a:srgbClr val="5B6B82"/>
                 </a:solidFill>
@@ -28854,20 +28971,20 @@
               </a:rPr>
               <a:t>≥ 3%</a:t>
             </a:r>
-            <a:endParaRPr lang="en-US" sz="5400" dirty="0"/>
+            <a:endParaRPr lang="en-US" sz="4400" dirty="0"/>
           </a:p>
         </p:txBody>
       </p:sp>
       <p:sp>
         <p:nvSpPr>
-          <p:cNvPr id="21" name="Text 18"/>
-          <p:cNvSpPr/>
-          <p:nvPr/>
-        </p:nvSpPr>
-        <p:spPr>
-          <a:xfrm>
-            <a:off x="822960" y="5303520"/>
-            <a:ext cx="3017520" cy="640080"/>
+          <p:cNvPr id="24" name="Text 21"/>
+          <p:cNvSpPr/>
+          <p:nvPr/>
+        </p:nvSpPr>
+        <p:spPr>
+          <a:xfrm>
+            <a:off x="822960" y="4663440"/>
+            <a:ext cx="3017520" cy="365760"/>
           </a:xfrm>
           <a:prstGeom prst="rect">
             <a:avLst/>
@@ -28883,7 +29000,46 @@
               <a:buNone/>
             </a:pPr>
             <a:r>
-              <a:rPr lang="en-US" sz="1800" dirty="0">
+              <a:rPr lang="en-US" sz="2000" b="1" dirty="0">
+                <a:solidFill>
+                  <a:srgbClr val="14213D"/>
+                </a:solidFill>
+                <a:latin typeface="Arial" pitchFamily="34" charset="0"/>
+                <a:ea typeface="Arial" pitchFamily="34" charset="-122"/>
+                <a:cs typeface="Arial" pitchFamily="34" charset="-120"/>
+              </a:rPr>
+              <a:t>Calon jadi Deal</a:t>
+            </a:r>
+            <a:endParaRPr lang="en-US" sz="2000" dirty="0"/>
+          </a:p>
+        </p:txBody>
+      </p:sp>
+      <p:sp>
+        <p:nvSpPr>
+          <p:cNvPr id="25" name="Text 22"/>
+          <p:cNvSpPr/>
+          <p:nvPr/>
+        </p:nvSpPr>
+        <p:spPr>
+          <a:xfrm>
+            <a:off x="822960" y="5074920"/>
+            <a:ext cx="3063240" cy="685800"/>
+          </a:xfrm>
+          <a:prstGeom prst="rect">
+            <a:avLst/>
+          </a:prstGeom>
+          <a:noFill/>
+          <a:ln/>
+        </p:spPr>
+        <p:txBody>
+          <a:bodyPr wrap="square" lIns="0" tIns="0" rIns="0" bIns="0" rtlCol="0" anchor="t"/>
+          <a:lstStyle/>
+          <a:p>
+            <a:pPr algn="l" indent="0" marL="0">
+              <a:buNone/>
+            </a:pPr>
+            <a:r>
+              <a:rPr lang="en-US" sz="1500" dirty="0">
                 <a:solidFill>
                   <a:srgbClr val="4F5A70"/>
                 </a:solidFill>
@@ -28891,26 +29047,26 @@
                 <a:ea typeface="Arial" pitchFamily="34" charset="-122"/>
                 <a:cs typeface="Arial" pitchFamily="34" charset="-120"/>
               </a:rPr>
-              <a:t>Dihubungi jadi Deal</a:t>
+              <a:t>Dari calon yang dihubungi, minimal 3 dari 100 jadi deal (asumsi awal).</a:t>
             </a:r>
-            <a:endParaRPr lang="en-US" sz="1800" dirty="0"/>
+            <a:endParaRPr lang="en-US" sz="1500" dirty="0"/>
           </a:p>
         </p:txBody>
       </p:sp>
       <p:sp>
         <p:nvSpPr>
-          <p:cNvPr id="22" name="Shape 19"/>
-          <p:cNvSpPr/>
-          <p:nvPr/>
-        </p:nvSpPr>
-        <p:spPr>
-          <a:xfrm>
-            <a:off x="4297680" y="3931920"/>
-            <a:ext cx="3566160" cy="2103120"/>
+          <p:cNvPr id="26" name="Shape 23"/>
+          <p:cNvSpPr/>
+          <p:nvPr/>
+        </p:nvSpPr>
+        <p:spPr>
+          <a:xfrm>
+            <a:off x="4297680" y="3749040"/>
+            <a:ext cx="3566160" cy="2057400"/>
           </a:xfrm>
           <a:prstGeom prst="roundRect">
             <a:avLst>
-              <a:gd name="adj" fmla="val 3478"/>
+              <a:gd name="adj" fmla="val 3556"/>
             </a:avLst>
           </a:prstGeom>
           <a:solidFill>
@@ -28933,14 +29089,14 @@
       </p:sp>
       <p:sp>
         <p:nvSpPr>
-          <p:cNvPr id="23" name="Text 20"/>
-          <p:cNvSpPr/>
-          <p:nvPr/>
-        </p:nvSpPr>
-        <p:spPr>
-          <a:xfrm>
-            <a:off x="4572000" y="4114800"/>
-            <a:ext cx="3017520" cy="1097280"/>
+          <p:cNvPr id="27" name="Text 24"/>
+          <p:cNvSpPr/>
+          <p:nvPr/>
+        </p:nvSpPr>
+        <p:spPr>
+          <a:xfrm>
+            <a:off x="4572000" y="3858768"/>
+            <a:ext cx="3017520" cy="777240"/>
           </a:xfrm>
           <a:prstGeom prst="rect">
             <a:avLst/>
@@ -28956,7 +29112,7 @@
               <a:buNone/>
             </a:pPr>
             <a:r>
-              <a:rPr lang="en-US" sz="5400" b="1" dirty="0">
+              <a:rPr lang="en-US" sz="4400" b="1" dirty="0">
                 <a:solidFill>
                   <a:srgbClr val="0F8B7D"/>
                 </a:solidFill>
@@ -28966,20 +29122,20 @@
               </a:rPr>
               <a:t>Rp0</a:t>
             </a:r>
-            <a:endParaRPr lang="en-US" sz="5400" dirty="0"/>
+            <a:endParaRPr lang="en-US" sz="4400" dirty="0"/>
           </a:p>
         </p:txBody>
       </p:sp>
       <p:sp>
         <p:nvSpPr>
-          <p:cNvPr id="24" name="Text 21"/>
-          <p:cNvSpPr/>
-          <p:nvPr/>
-        </p:nvSpPr>
-        <p:spPr>
-          <a:xfrm>
-            <a:off x="4572000" y="5303520"/>
-            <a:ext cx="3017520" cy="640080"/>
+          <p:cNvPr id="28" name="Text 25"/>
+          <p:cNvSpPr/>
+          <p:nvPr/>
+        </p:nvSpPr>
+        <p:spPr>
+          <a:xfrm>
+            <a:off x="4572000" y="4663440"/>
+            <a:ext cx="3017520" cy="365760"/>
           </a:xfrm>
           <a:prstGeom prst="rect">
             <a:avLst/>
@@ -28995,7 +29151,46 @@
               <a:buNone/>
             </a:pPr>
             <a:r>
-              <a:rPr lang="en-US" sz="1800" dirty="0">
+              <a:rPr lang="en-US" sz="2000" b="1" dirty="0">
+                <a:solidFill>
+                  <a:srgbClr val="14213D"/>
+                </a:solidFill>
+                <a:latin typeface="Arial" pitchFamily="34" charset="0"/>
+                <a:ea typeface="Arial" pitchFamily="34" charset="-122"/>
+                <a:cs typeface="Arial" pitchFamily="34" charset="-120"/>
+              </a:rPr>
+              <a:t>Biaya data</a:t>
+            </a:r>
+            <a:endParaRPr lang="en-US" sz="2000" dirty="0"/>
+          </a:p>
+        </p:txBody>
+      </p:sp>
+      <p:sp>
+        <p:nvSpPr>
+          <p:cNvPr id="29" name="Text 26"/>
+          <p:cNvSpPr/>
+          <p:nvPr/>
+        </p:nvSpPr>
+        <p:spPr>
+          <a:xfrm>
+            <a:off x="4572000" y="5074920"/>
+            <a:ext cx="3063240" cy="685800"/>
+          </a:xfrm>
+          <a:prstGeom prst="rect">
+            <a:avLst/>
+          </a:prstGeom>
+          <a:noFill/>
+          <a:ln/>
+        </p:spPr>
+        <p:txBody>
+          <a:bodyPr wrap="square" lIns="0" tIns="0" rIns="0" bIns="0" rtlCol="0" anchor="t"/>
+          <a:lstStyle/>
+          <a:p>
+            <a:pPr algn="l" indent="0" marL="0">
+              <a:buNone/>
+            </a:pPr>
+            <a:r>
+              <a:rPr lang="en-US" sz="1500" dirty="0">
                 <a:solidFill>
                   <a:srgbClr val="4F5A70"/>
                 </a:solidFill>
@@ -29003,26 +29198,26 @@
                 <a:ea typeface="Arial" pitchFamily="34" charset="-122"/>
                 <a:cs typeface="Arial" pitchFamily="34" charset="-120"/>
               </a:rPr>
-              <a:t>biaya data (OpenStreetMap)</a:t>
+              <a:t>Memakai OpenStreetMap yang gratis. Google hanya opsional.</a:t>
             </a:r>
-            <a:endParaRPr lang="en-US" sz="1800" dirty="0"/>
+            <a:endParaRPr lang="en-US" sz="1500" dirty="0"/>
           </a:p>
         </p:txBody>
       </p:sp>
       <p:sp>
         <p:nvSpPr>
-          <p:cNvPr id="25" name="Shape 22"/>
-          <p:cNvSpPr/>
-          <p:nvPr/>
-        </p:nvSpPr>
-        <p:spPr>
-          <a:xfrm>
-            <a:off x="8046720" y="3931920"/>
-            <a:ext cx="3566160" cy="2103120"/>
+          <p:cNvPr id="30" name="Shape 27"/>
+          <p:cNvSpPr/>
+          <p:nvPr/>
+        </p:nvSpPr>
+        <p:spPr>
+          <a:xfrm>
+            <a:off x="8046720" y="3749040"/>
+            <a:ext cx="3566160" cy="2057400"/>
           </a:xfrm>
           <a:prstGeom prst="roundRect">
             <a:avLst>
-              <a:gd name="adj" fmla="val 3478"/>
+              <a:gd name="adj" fmla="val 3556"/>
             </a:avLst>
           </a:prstGeom>
           <a:solidFill>
@@ -29045,14 +29240,14 @@
       </p:sp>
       <p:sp>
         <p:nvSpPr>
-          <p:cNvPr id="26" name="Text 23"/>
-          <p:cNvSpPr/>
-          <p:nvPr/>
-        </p:nvSpPr>
-        <p:spPr>
-          <a:xfrm>
-            <a:off x="8321040" y="4114800"/>
-            <a:ext cx="3017520" cy="1097280"/>
+          <p:cNvPr id="31" name="Text 28"/>
+          <p:cNvSpPr/>
+          <p:nvPr/>
+        </p:nvSpPr>
+        <p:spPr>
+          <a:xfrm>
+            <a:off x="8321040" y="3858768"/>
+            <a:ext cx="3017520" cy="777240"/>
           </a:xfrm>
           <a:prstGeom prst="rect">
             <a:avLst/>
@@ -29068,7 +29263,7 @@
               <a:buNone/>
             </a:pPr>
             <a:r>
-              <a:rPr lang="en-US" sz="5400" b="1" dirty="0">
+              <a:rPr lang="en-US" sz="4400" b="1" dirty="0">
                 <a:solidFill>
                   <a:srgbClr val="14213D"/>
                 </a:solidFill>
@@ -29078,20 +29273,20 @@
               </a:rPr>
               <a:t>≥ 80%</a:t>
             </a:r>
-            <a:endParaRPr lang="en-US" sz="5400" dirty="0"/>
+            <a:endParaRPr lang="en-US" sz="4400" dirty="0"/>
           </a:p>
         </p:txBody>
       </p:sp>
       <p:sp>
         <p:nvSpPr>
-          <p:cNvPr id="27" name="Text 24"/>
-          <p:cNvSpPr/>
-          <p:nvPr/>
-        </p:nvSpPr>
-        <p:spPr>
-          <a:xfrm>
-            <a:off x="8321040" y="5303520"/>
-            <a:ext cx="3017520" cy="640080"/>
+          <p:cNvPr id="32" name="Text 29"/>
+          <p:cNvSpPr/>
+          <p:nvPr/>
+        </p:nvSpPr>
+        <p:spPr>
+          <a:xfrm>
+            <a:off x="8321040" y="4663440"/>
+            <a:ext cx="3017520" cy="365760"/>
           </a:xfrm>
           <a:prstGeom prst="rect">
             <a:avLst/>
@@ -29107,7 +29302,46 @@
               <a:buNone/>
             </a:pPr>
             <a:r>
-              <a:rPr lang="en-US" sz="1800" dirty="0">
+              <a:rPr lang="en-US" sz="2000" b="1" dirty="0">
+                <a:solidFill>
+                  <a:srgbClr val="14213D"/>
+                </a:solidFill>
+                <a:latin typeface="Arial" pitchFamily="34" charset="0"/>
+                <a:ea typeface="Arial" pitchFamily="34" charset="-122"/>
+                <a:cs typeface="Arial" pitchFamily="34" charset="-120"/>
+              </a:rPr>
+              <a:t>Akun aktif</a:t>
+            </a:r>
+            <a:endParaRPr lang="en-US" sz="2000" dirty="0"/>
+          </a:p>
+        </p:txBody>
+      </p:sp>
+      <p:sp>
+        <p:nvSpPr>
+          <p:cNvPr id="33" name="Text 30"/>
+          <p:cNvSpPr/>
+          <p:nvPr/>
+        </p:nvSpPr>
+        <p:spPr>
+          <a:xfrm>
+            <a:off x="8321040" y="5074920"/>
+            <a:ext cx="3063240" cy="685800"/>
+          </a:xfrm>
+          <a:prstGeom prst="rect">
+            <a:avLst/>
+          </a:prstGeom>
+          <a:noFill/>
+          <a:ln/>
+        </p:spPr>
+        <p:txBody>
+          <a:bodyPr wrap="square" lIns="0" tIns="0" rIns="0" bIns="0" rtlCol="0" anchor="t"/>
+          <a:lstStyle/>
+          <a:p>
+            <a:pPr algn="l" indent="0" marL="0">
+              <a:buNone/>
+            </a:pPr>
+            <a:r>
+              <a:rPr lang="en-US" sz="1500" dirty="0">
                 <a:solidFill>
                   <a:srgbClr val="4F5A70"/>
                 </a:solidFill>
@@ -29115,9 +29349,48 @@
                 <a:ea typeface="Arial" pitchFamily="34" charset="-122"/>
                 <a:cs typeface="Arial" pitchFamily="34" charset="-120"/>
               </a:rPr>
-              <a:t>akun aktif tiap minggu</a:t>
+              <a:t>Minimal 8 dari 10 akun terdaftar dipakai setiap minggu.</a:t>
             </a:r>
-            <a:endParaRPr lang="en-US" sz="1800" dirty="0"/>
+            <a:endParaRPr lang="en-US" sz="1500" dirty="0"/>
+          </a:p>
+        </p:txBody>
+      </p:sp>
+      <p:sp>
+        <p:nvSpPr>
+          <p:cNvPr id="34" name="Text 31"/>
+          <p:cNvSpPr/>
+          <p:nvPr/>
+        </p:nvSpPr>
+        <p:spPr>
+          <a:xfrm>
+            <a:off x="548640" y="5989320"/>
+            <a:ext cx="10972800" cy="320040"/>
+          </a:xfrm>
+          <a:prstGeom prst="rect">
+            <a:avLst/>
+          </a:prstGeom>
+          <a:noFill/>
+          <a:ln/>
+        </p:spPr>
+        <p:txBody>
+          <a:bodyPr wrap="square" lIns="0" tIns="0" rIns="0" bIns="0" rtlCol="0" anchor="t"/>
+          <a:lstStyle/>
+          <a:p>
+            <a:pPr algn="l" indent="0" marL="0">
+              <a:buNone/>
+            </a:pPr>
+            <a:r>
+              <a:rPr lang="en-US" sz="1600" i="1" dirty="0">
+                <a:solidFill>
+                  <a:srgbClr val="4F5A70"/>
+                </a:solidFill>
+                <a:latin typeface="Arial" pitchFamily="34" charset="0"/>
+                <a:ea typeface="Arial" pitchFamily="34" charset="-122"/>
+                <a:cs typeface="Arial" pitchFamily="34" charset="-120"/>
+              </a:rPr>
+              <a:t>Diukur selama pilot 90 hari dan dibaca langsung dari Dasbor.</a:t>
+            </a:r>
+            <a:endParaRPr lang="en-US" sz="1600" dirty="0"/>
           </a:p>
         </p:txBody>
       </p:sp>
@@ -29190,7 +29463,7 @@
                               <p:par>
                                 <p:cTn id="8" presetID="10" presetClass="entr" presetSubtype="0" fill="hold" nodeType="withEffect">
                                   <p:stCondLst>
-                                    <p:cond delay="100"/>
+                                    <p:cond delay="72"/>
                                   </p:stCondLst>
                                   <p:childTnLst>
                                     <p:set>
@@ -29225,7 +29498,7 @@
                               <p:par>
                                 <p:cTn id="11" presetID="10" presetClass="entr" presetSubtype="0" fill="hold" nodeType="withEffect">
                                   <p:stCondLst>
-                                    <p:cond delay="200"/>
+                                    <p:cond delay="144"/>
                                   </p:stCondLst>
                                   <p:childTnLst>
                                     <p:set>
@@ -29260,7 +29533,7 @@
                               <p:par>
                                 <p:cTn id="14" presetID="10" presetClass="entr" presetSubtype="0" fill="hold" nodeType="withEffect">
                                   <p:stCondLst>
-                                    <p:cond delay="300"/>
+                                    <p:cond delay="216"/>
                                   </p:stCondLst>
                                   <p:childTnLst>
                                     <p:set>
@@ -29295,7 +29568,7 @@
                               <p:par>
                                 <p:cTn id="17" presetID="10" presetClass="entr" presetSubtype="0" fill="hold" nodeType="withEffect">
                                   <p:stCondLst>
-                                    <p:cond delay="400"/>
+                                    <p:cond delay="288"/>
                                   </p:stCondLst>
                                   <p:childTnLst>
                                     <p:set>
@@ -29330,7 +29603,7 @@
                               <p:par>
                                 <p:cTn id="20" presetID="10" presetClass="entr" presetSubtype="0" fill="hold" nodeType="withEffect">
                                   <p:stCondLst>
-                                    <p:cond delay="500"/>
+                                    <p:cond delay="360"/>
                                   </p:stCondLst>
                                   <p:childTnLst>
                                     <p:set>
@@ -29365,7 +29638,7 @@
                               <p:par>
                                 <p:cTn id="23" presetID="10" presetClass="entr" presetSubtype="0" fill="hold" nodeType="withEffect">
                                   <p:stCondLst>
-                                    <p:cond delay="600"/>
+                                    <p:cond delay="432"/>
                                   </p:stCondLst>
                                   <p:childTnLst>
                                     <p:set>
@@ -29400,7 +29673,7 @@
                               <p:par>
                                 <p:cTn id="26" presetID="10" presetClass="entr" presetSubtype="0" fill="hold" nodeType="withEffect">
                                   <p:stCondLst>
-                                    <p:cond delay="700"/>
+                                    <p:cond delay="504"/>
                                   </p:stCondLst>
                                   <p:childTnLst>
                                     <p:set>
@@ -29435,7 +29708,7 @@
                               <p:par>
                                 <p:cTn id="29" presetID="10" presetClass="entr" presetSubtype="0" fill="hold" nodeType="withEffect">
                                   <p:stCondLst>
-                                    <p:cond delay="800"/>
+                                    <p:cond delay="576"/>
                                   </p:stCondLst>
                                   <p:childTnLst>
                                     <p:set>
@@ -29470,7 +29743,7 @@
                               <p:par>
                                 <p:cTn id="32" presetID="10" presetClass="entr" presetSubtype="0" fill="hold" nodeType="withEffect">
                                   <p:stCondLst>
-                                    <p:cond delay="900"/>
+                                    <p:cond delay="648"/>
                                   </p:stCondLst>
                                   <p:childTnLst>
                                     <p:set>
@@ -29505,7 +29778,7 @@
                               <p:par>
                                 <p:cTn id="35" presetID="10" presetClass="entr" presetSubtype="0" fill="hold" nodeType="withEffect">
                                   <p:stCondLst>
-                                    <p:cond delay="1000"/>
+                                    <p:cond delay="720"/>
                                   </p:stCondLst>
                                   <p:childTnLst>
                                     <p:set>
@@ -29540,7 +29813,7 @@
                               <p:par>
                                 <p:cTn id="38" presetID="10" presetClass="entr" presetSubtype="0" fill="hold" nodeType="withEffect">
                                   <p:stCondLst>
-                                    <p:cond delay="1100"/>
+                                    <p:cond delay="792"/>
                                   </p:stCondLst>
                                   <p:childTnLst>
                                     <p:set>
@@ -29575,7 +29848,7 @@
                               <p:par>
                                 <p:cTn id="41" presetID="10" presetClass="entr" presetSubtype="0" fill="hold" nodeType="withEffect">
                                   <p:stCondLst>
-                                    <p:cond delay="1200"/>
+                                    <p:cond delay="864"/>
                                   </p:stCondLst>
                                   <p:childTnLst>
                                     <p:set>
@@ -29610,7 +29883,7 @@
                               <p:par>
                                 <p:cTn id="44" presetID="10" presetClass="entr" presetSubtype="0" fill="hold" nodeType="withEffect">
                                   <p:stCondLst>
-                                    <p:cond delay="1300"/>
+                                    <p:cond delay="936"/>
                                   </p:stCondLst>
                                   <p:childTnLst>
                                     <p:set>
@@ -29645,7 +29918,7 @@
                               <p:par>
                                 <p:cTn id="47" presetID="10" presetClass="entr" presetSubtype="0" fill="hold" nodeType="withEffect">
                                   <p:stCondLst>
-                                    <p:cond delay="1400"/>
+                                    <p:cond delay="1008"/>
                                   </p:stCondLst>
                                   <p:childTnLst>
                                     <p:set>
@@ -29680,7 +29953,7 @@
                               <p:par>
                                 <p:cTn id="50" presetID="10" presetClass="entr" presetSubtype="0" fill="hold" nodeType="withEffect">
                                   <p:stCondLst>
-                                    <p:cond delay="1500"/>
+                                    <p:cond delay="1080"/>
                                   </p:stCondLst>
                                   <p:childTnLst>
                                     <p:set>
@@ -29715,7 +29988,7 @@
                               <p:par>
                                 <p:cTn id="53" presetID="10" presetClass="entr" presetSubtype="0" fill="hold" nodeType="withEffect">
                                   <p:stCondLst>
-                                    <p:cond delay="1600"/>
+                                    <p:cond delay="1152"/>
                                   </p:stCondLst>
                                   <p:childTnLst>
                                     <p:set>
@@ -29750,7 +30023,7 @@
                               <p:par>
                                 <p:cTn id="56" presetID="10" presetClass="entr" presetSubtype="0" fill="hold" nodeType="withEffect">
                                   <p:stCondLst>
-                                    <p:cond delay="1700"/>
+                                    <p:cond delay="1224"/>
                                   </p:stCondLst>
                                   <p:childTnLst>
                                     <p:set>
@@ -29776,6 +30049,251 @@
                                         <p:cTn id="58" dur="450"/>
                                         <p:tgtEl>
                                           <p:spTgt spid="27"/>
+                                        </p:tgtEl>
+                                      </p:cBhvr>
+                                    </p:animEffect>
+                                  </p:childTnLst>
+                                </p:cTn>
+                              </p:par>
+                              <p:par>
+                                <p:cTn id="59" presetID="10" presetClass="entr" presetSubtype="0" fill="hold" nodeType="withEffect">
+                                  <p:stCondLst>
+                                    <p:cond delay="1296"/>
+                                  </p:stCondLst>
+                                  <p:childTnLst>
+                                    <p:set>
+                                      <p:cBhvr>
+                                        <p:cTn id="60" dur="1" fill="hold">
+                                          <p:stCondLst>
+                                            <p:cond delay="0"/>
+                                          </p:stCondLst>
+                                        </p:cTn>
+                                        <p:tgtEl>
+                                          <p:spTgt spid="28"/>
+                                        </p:tgtEl>
+                                        <p:attrNameLst>
+                                          <p:attrName>style.visibility</p:attrName>
+                                        </p:attrNameLst>
+                                      </p:cBhvr>
+                                      <p:to>
+                                        <p:strVal val="visible"/>
+                                      </p:to>
+                                    </p:set>
+                                    <p:animEffect transition="in" filter="fade">
+                                      <p:cBhvr>
+                                        <p:cTn id="61" dur="450"/>
+                                        <p:tgtEl>
+                                          <p:spTgt spid="28"/>
+                                        </p:tgtEl>
+                                      </p:cBhvr>
+                                    </p:animEffect>
+                                  </p:childTnLst>
+                                </p:cTn>
+                              </p:par>
+                              <p:par>
+                                <p:cTn id="62" presetID="10" presetClass="entr" presetSubtype="0" fill="hold" nodeType="withEffect">
+                                  <p:stCondLst>
+                                    <p:cond delay="1368"/>
+                                  </p:stCondLst>
+                                  <p:childTnLst>
+                                    <p:set>
+                                      <p:cBhvr>
+                                        <p:cTn id="63" dur="1" fill="hold">
+                                          <p:stCondLst>
+                                            <p:cond delay="0"/>
+                                          </p:stCondLst>
+                                        </p:cTn>
+                                        <p:tgtEl>
+                                          <p:spTgt spid="29"/>
+                                        </p:tgtEl>
+                                        <p:attrNameLst>
+                                          <p:attrName>style.visibility</p:attrName>
+                                        </p:attrNameLst>
+                                      </p:cBhvr>
+                                      <p:to>
+                                        <p:strVal val="visible"/>
+                                      </p:to>
+                                    </p:set>
+                                    <p:animEffect transition="in" filter="fade">
+                                      <p:cBhvr>
+                                        <p:cTn id="64" dur="450"/>
+                                        <p:tgtEl>
+                                          <p:spTgt spid="29"/>
+                                        </p:tgtEl>
+                                      </p:cBhvr>
+                                    </p:animEffect>
+                                  </p:childTnLst>
+                                </p:cTn>
+                              </p:par>
+                              <p:par>
+                                <p:cTn id="65" presetID="10" presetClass="entr" presetSubtype="0" fill="hold" nodeType="withEffect">
+                                  <p:stCondLst>
+                                    <p:cond delay="1440"/>
+                                  </p:stCondLst>
+                                  <p:childTnLst>
+                                    <p:set>
+                                      <p:cBhvr>
+                                        <p:cTn id="66" dur="1" fill="hold">
+                                          <p:stCondLst>
+                                            <p:cond delay="0"/>
+                                          </p:stCondLst>
+                                        </p:cTn>
+                                        <p:tgtEl>
+                                          <p:spTgt spid="30"/>
+                                        </p:tgtEl>
+                                        <p:attrNameLst>
+                                          <p:attrName>style.visibility</p:attrName>
+                                        </p:attrNameLst>
+                                      </p:cBhvr>
+                                      <p:to>
+                                        <p:strVal val="visible"/>
+                                      </p:to>
+                                    </p:set>
+                                    <p:animEffect transition="in" filter="fade">
+                                      <p:cBhvr>
+                                        <p:cTn id="67" dur="450"/>
+                                        <p:tgtEl>
+                                          <p:spTgt spid="30"/>
+                                        </p:tgtEl>
+                                      </p:cBhvr>
+                                    </p:animEffect>
+                                  </p:childTnLst>
+                                </p:cTn>
+                              </p:par>
+                              <p:par>
+                                <p:cTn id="68" presetID="10" presetClass="entr" presetSubtype="0" fill="hold" nodeType="withEffect">
+                                  <p:stCondLst>
+                                    <p:cond delay="1512"/>
+                                  </p:stCondLst>
+                                  <p:childTnLst>
+                                    <p:set>
+                                      <p:cBhvr>
+                                        <p:cTn id="69" dur="1" fill="hold">
+                                          <p:stCondLst>
+                                            <p:cond delay="0"/>
+                                          </p:stCondLst>
+                                        </p:cTn>
+                                        <p:tgtEl>
+                                          <p:spTgt spid="31"/>
+                                        </p:tgtEl>
+                                        <p:attrNameLst>
+                                          <p:attrName>style.visibility</p:attrName>
+                                        </p:attrNameLst>
+                                      </p:cBhvr>
+                                      <p:to>
+                                        <p:strVal val="visible"/>
+                                      </p:to>
+                                    </p:set>
+                                    <p:animEffect transition="in" filter="fade">
+                                      <p:cBhvr>
+                                        <p:cTn id="70" dur="450"/>
+                                        <p:tgtEl>
+                                          <p:spTgt spid="31"/>
+                                        </p:tgtEl>
+                                      </p:cBhvr>
+                                    </p:animEffect>
+                                  </p:childTnLst>
+                                </p:cTn>
+                              </p:par>
+                              <p:par>
+                                <p:cTn id="71" presetID="10" presetClass="entr" presetSubtype="0" fill="hold" nodeType="withEffect">
+                                  <p:stCondLst>
+                                    <p:cond delay="1584"/>
+                                  </p:stCondLst>
+                                  <p:childTnLst>
+                                    <p:set>
+                                      <p:cBhvr>
+                                        <p:cTn id="72" dur="1" fill="hold">
+                                          <p:stCondLst>
+                                            <p:cond delay="0"/>
+                                          </p:stCondLst>
+                                        </p:cTn>
+                                        <p:tgtEl>
+                                          <p:spTgt spid="32"/>
+                                        </p:tgtEl>
+                                        <p:attrNameLst>
+                                          <p:attrName>style.visibility</p:attrName>
+                                        </p:attrNameLst>
+                                      </p:cBhvr>
+                                      <p:to>
+                                        <p:strVal val="visible"/>
+                                      </p:to>
+                                    </p:set>
+                                    <p:animEffect transition="in" filter="fade">
+                                      <p:cBhvr>
+                                        <p:cTn id="73" dur="450"/>
+                                        <p:tgtEl>
+                                          <p:spTgt spid="32"/>
+                                        </p:tgtEl>
+                                      </p:cBhvr>
+                                    </p:animEffect>
+                                  </p:childTnLst>
+                                </p:cTn>
+                              </p:par>
+                              <p:par>
+                                <p:cTn id="74" presetID="10" presetClass="entr" presetSubtype="0" fill="hold" nodeType="withEffect">
+                                  <p:stCondLst>
+                                    <p:cond delay="1656"/>
+                                  </p:stCondLst>
+                                  <p:childTnLst>
+                                    <p:set>
+                                      <p:cBhvr>
+                                        <p:cTn id="75" dur="1" fill="hold">
+                                          <p:stCondLst>
+                                            <p:cond delay="0"/>
+                                          </p:stCondLst>
+                                        </p:cTn>
+                                        <p:tgtEl>
+                                          <p:spTgt spid="33"/>
+                                        </p:tgtEl>
+                                        <p:attrNameLst>
+                                          <p:attrName>style.visibility</p:attrName>
+                                        </p:attrNameLst>
+                                      </p:cBhvr>
+                                      <p:to>
+                                        <p:strVal val="visible"/>
+                                      </p:to>
+                                    </p:set>
+                                    <p:animEffect transition="in" filter="fade">
+                                      <p:cBhvr>
+                                        <p:cTn id="76" dur="450"/>
+                                        <p:tgtEl>
+                                          <p:spTgt spid="33"/>
+                                        </p:tgtEl>
+                                      </p:cBhvr>
+                                    </p:animEffect>
+                                  </p:childTnLst>
+                                </p:cTn>
+                              </p:par>
+                              <p:par>
+                                <p:cTn id="77" presetID="10" presetClass="entr" presetSubtype="0" fill="hold" nodeType="withEffect">
+                                  <p:stCondLst>
+                                    <p:cond delay="1728"/>
+                                  </p:stCondLst>
+                                  <p:childTnLst>
+                                    <p:set>
+                                      <p:cBhvr>
+                                        <p:cTn id="78" dur="1" fill="hold">
+                                          <p:stCondLst>
+                                            <p:cond delay="0"/>
+                                          </p:stCondLst>
+                                        </p:cTn>
+                                        <p:tgtEl>
+                                          <p:spTgt spid="34"/>
+                                        </p:tgtEl>
+                                        <p:attrNameLst>
+                                          <p:attrName>style.visibility</p:attrName>
+                                        </p:attrNameLst>
+                                      </p:cBhvr>
+                                      <p:to>
+                                        <p:strVal val="visible"/>
+                                      </p:to>
+                                    </p:set>
+                                    <p:animEffect transition="in" filter="fade">
+                                      <p:cBhvr>
+                                        <p:cTn id="79" dur="450"/>
+                                        <p:tgtEl>
+                                          <p:spTgt spid="34"/>
                                         </p:tgtEl>
                                       </p:cBhvr>
                                     </p:animEffect>

</xml_diff>